<commit_message>
Presentation and output updates
</commit_message>
<xml_diff>
--- a/dubuko_ucenje_projekat_ppt.pptx
+++ b/dubuko_ucenje_projekat_ppt.pptx
@@ -4413,7 +4413,7 @@
           <a:p>
             <a:fld id="{48A87A34-81AB-432B-8DAE-1953F412C126}" type="datetimeFigureOut">
               <a:rPr lang="en-US" dirty="0"/>
-              <a:t>5/17/2026</a:t>
+              <a:t>13-Jun-26</a:t>
             </a:fld>
             <a:endParaRPr lang="en-US"/>
           </a:p>
@@ -4673,7 +4673,7 @@
           <a:p>
             <a:fld id="{48A87A34-81AB-432B-8DAE-1953F412C126}" type="datetimeFigureOut">
               <a:rPr lang="en-US" dirty="0"/>
-              <a:t>5/17/2026</a:t>
+              <a:t>13-Jun-26</a:t>
             </a:fld>
             <a:endParaRPr lang="en-US"/>
           </a:p>
@@ -4863,7 +4863,7 @@
           <a:p>
             <a:fld id="{48A87A34-81AB-432B-8DAE-1953F412C126}" type="datetimeFigureOut">
               <a:rPr lang="en-US" dirty="0"/>
-              <a:t>5/17/2026</a:t>
+              <a:t>13-Jun-26</a:t>
             </a:fld>
             <a:endParaRPr lang="en-US"/>
           </a:p>
@@ -5120,7 +5120,7 @@
           <a:p>
             <a:fld id="{48A87A34-81AB-432B-8DAE-1953F412C126}" type="datetimeFigureOut">
               <a:rPr lang="en-US" dirty="0"/>
-              <a:t>5/17/2026</a:t>
+              <a:t>13-Jun-26</a:t>
             </a:fld>
             <a:endParaRPr lang="en-US"/>
           </a:p>
@@ -5548,7 +5548,7 @@
           <a:p>
             <a:fld id="{48A87A34-81AB-432B-8DAE-1953F412C126}" type="datetimeFigureOut">
               <a:rPr lang="en-US" dirty="0"/>
-              <a:t>5/17/2026</a:t>
+              <a:t>13-Jun-26</a:t>
             </a:fld>
             <a:endParaRPr lang="en-US"/>
           </a:p>
@@ -6088,7 +6088,7 @@
           <a:p>
             <a:fld id="{48A87A34-81AB-432B-8DAE-1953F412C126}" type="datetimeFigureOut">
               <a:rPr lang="en-US" dirty="0"/>
-              <a:t>5/17/2026</a:t>
+              <a:t>13-Jun-26</a:t>
             </a:fld>
             <a:endParaRPr lang="en-US"/>
           </a:p>
@@ -6799,7 +6799,7 @@
           <a:p>
             <a:fld id="{48A87A34-81AB-432B-8DAE-1953F412C126}" type="datetimeFigureOut">
               <a:rPr lang="en-US" dirty="0"/>
-              <a:t>5/17/2026</a:t>
+              <a:t>13-Jun-26</a:t>
             </a:fld>
             <a:endParaRPr lang="en-US"/>
           </a:p>
@@ -6962,7 +6962,7 @@
           <a:p>
             <a:fld id="{48A87A34-81AB-432B-8DAE-1953F412C126}" type="datetimeFigureOut">
               <a:rPr lang="en-US" dirty="0"/>
-              <a:t>5/17/2026</a:t>
+              <a:t>13-Jun-26</a:t>
             </a:fld>
             <a:endParaRPr lang="en-US"/>
           </a:p>
@@ -7135,7 +7135,7 @@
           <a:p>
             <a:fld id="{48A87A34-81AB-432B-8DAE-1953F412C126}" type="datetimeFigureOut">
               <a:rPr lang="en-US" dirty="0"/>
-              <a:t>5/17/2026</a:t>
+              <a:t>13-Jun-26</a:t>
             </a:fld>
             <a:endParaRPr lang="en-US"/>
           </a:p>
@@ -7298,7 +7298,7 @@
           <a:p>
             <a:fld id="{48A87A34-81AB-432B-8DAE-1953F412C126}" type="datetimeFigureOut">
               <a:rPr lang="en-US" dirty="0"/>
-              <a:t>5/17/2026</a:t>
+              <a:t>13-Jun-26</a:t>
             </a:fld>
             <a:endParaRPr lang="en-US"/>
           </a:p>
@@ -7542,7 +7542,7 @@
           <a:p>
             <a:fld id="{48A87A34-81AB-432B-8DAE-1953F412C126}" type="datetimeFigureOut">
               <a:rPr lang="en-US" dirty="0"/>
-              <a:t>5/17/2026</a:t>
+              <a:t>13-Jun-26</a:t>
             </a:fld>
             <a:endParaRPr lang="en-US"/>
           </a:p>
@@ -7766,7 +7766,7 @@
           <a:p>
             <a:fld id="{48A87A34-81AB-432B-8DAE-1953F412C126}" type="datetimeFigureOut">
               <a:rPr lang="en-US" dirty="0"/>
-              <a:t>5/17/2026</a:t>
+              <a:t>13-Jun-26</a:t>
             </a:fld>
             <a:endParaRPr lang="en-US"/>
           </a:p>
@@ -8139,7 +8139,7 @@
           <a:p>
             <a:fld id="{48A87A34-81AB-432B-8DAE-1953F412C126}" type="datetimeFigureOut">
               <a:rPr lang="en-US" dirty="0"/>
-              <a:t>5/17/2026</a:t>
+              <a:t>13-Jun-26</a:t>
             </a:fld>
             <a:endParaRPr lang="en-US"/>
           </a:p>
@@ -8251,7 +8251,7 @@
           <a:p>
             <a:fld id="{48A87A34-81AB-432B-8DAE-1953F412C126}" type="datetimeFigureOut">
               <a:rPr lang="en-US" dirty="0"/>
-              <a:t>5/17/2026</a:t>
+              <a:t>13-Jun-26</a:t>
             </a:fld>
             <a:endParaRPr lang="en-US"/>
           </a:p>
@@ -8341,7 +8341,7 @@
           <a:p>
             <a:fld id="{48A87A34-81AB-432B-8DAE-1953F412C126}" type="datetimeFigureOut">
               <a:rPr lang="en-US" dirty="0"/>
-              <a:t>5/17/2026</a:t>
+              <a:t>13-Jun-26</a:t>
             </a:fld>
             <a:endParaRPr lang="en-US"/>
           </a:p>
@@ -8583,7 +8583,7 @@
           <a:p>
             <a:fld id="{48A87A34-81AB-432B-8DAE-1953F412C126}" type="datetimeFigureOut">
               <a:rPr lang="en-US" dirty="0"/>
-              <a:t>5/17/2026</a:t>
+              <a:t>13-Jun-26</a:t>
             </a:fld>
             <a:endParaRPr lang="en-US"/>
           </a:p>
@@ -8856,7 +8856,7 @@
           <a:p>
             <a:fld id="{48A87A34-81AB-432B-8DAE-1953F412C126}" type="datetimeFigureOut">
               <a:rPr lang="en-US" dirty="0"/>
-              <a:t>5/17/2026</a:t>
+              <a:t>13-Jun-26</a:t>
             </a:fld>
             <a:endParaRPr lang="en-US"/>
           </a:p>
@@ -11928,7 +11928,7 @@
             <a:fld id="{48A87A34-81AB-432B-8DAE-1953F412C126}" type="datetimeFigureOut">
               <a:rPr lang="en-US" dirty="0"/>
               <a:pPr/>
-              <a:t>5/17/2026</a:t>
+              <a:t>13-Jun-26</a:t>
             </a:fld>
             <a:endParaRPr lang="en-US"/>
           </a:p>
@@ -12374,29 +12374,33 @@
           <a:p>
             <a:pPr algn="ctr"/>
             <a:r>
-              <a:rPr lang="en-US" sz="4000" err="1"/>
+              <a:rPr lang="en-US" sz="4000" dirty="0" err="1"/>
               <a:t>Dubuko</a:t>
             </a:r>
             <a:r>
-              <a:rPr lang="en-US" sz="4000"/>
-              <a:t> </a:t>
-            </a:r>
-            <a:r>
-              <a:rPr lang="en-US" sz="4000" err="1"/>
-              <a:t>ucenje</a:t>
-            </a:r>
-            <a:r>
-              <a:rPr lang="en-US" sz="4000"/>
+              <a:rPr lang="en-US" sz="4000" dirty="0"/>
+              <a:t> u</a:t>
+            </a:r>
+            <a:r>
+              <a:rPr lang="sr-Latn-RS" sz="4000" dirty="0"/>
+              <a:t>Č</a:t>
+            </a:r>
+            <a:r>
+              <a:rPr lang="en-US" sz="4000" dirty="0" err="1"/>
+              <a:t>enje</a:t>
+            </a:r>
+            <a:r>
+              <a:rPr lang="en-US" sz="4000" dirty="0"/>
               <a:t> - </a:t>
             </a:r>
             <a:r>
-              <a:rPr lang="en-US" sz="4000" err="1"/>
+              <a:rPr lang="en-US" sz="4000" dirty="0" err="1"/>
               <a:t>projekat</a:t>
             </a:r>
             <a:br>
-              <a:rPr lang="en-US" sz="4000"/>
+              <a:rPr lang="en-US" sz="4000" dirty="0"/>
             </a:br>
-            <a:endParaRPr lang="en-US" sz="4000"/>
+            <a:endParaRPr lang="en-US" sz="4000" dirty="0"/>
           </a:p>
         </p:txBody>
       </p:sp>
@@ -12430,51 +12434,47 @@
           <a:p>
             <a:pPr algn="ctr"/>
             <a:r>
-              <a:rPr lang="en-US" sz="3000" err="1"/>
+              <a:rPr lang="en-US" sz="3000" dirty="0" err="1"/>
               <a:t>Predviđanje</a:t>
-            </a:r>
-            <a:r>
-              <a:rPr lang="en-US" sz="3000"/>
-              <a:t> </a:t>
-            </a:r>
-            <a:r>
-              <a:rPr lang="en-US" sz="3000" err="1"/>
-              <a:t>ugla</a:t>
             </a:r>
             <a:r>
               <a:rPr lang="en-US" sz="3000" dirty="0"/>
               <a:t> </a:t>
             </a:r>
             <a:r>
-              <a:rPr lang="en-US" sz="3000" err="1"/>
-              <a:t>upravljanja</a:t>
+              <a:rPr lang="en-US" sz="3000" dirty="0" err="1"/>
+              <a:t>ugla</a:t>
             </a:r>
             <a:r>
               <a:rPr lang="en-US" sz="3000" dirty="0"/>
               <a:t> </a:t>
             </a:r>
             <a:r>
-              <a:rPr lang="en-US" sz="3000" err="1"/>
-              <a:t>vozila</a:t>
-            </a:r>
-            <a:r>
-              <a:rPr lang="en-US" sz="3000"/>
-              <a:t> (</a:t>
-            </a:r>
-            <a:r>
-              <a:rPr lang="en-US" sz="3000" err="1"/>
-              <a:t>eng.</a:t>
+              <a:rPr lang="en-US" sz="3000" dirty="0" err="1"/>
+              <a:t>upravljanja</a:t>
             </a:r>
             <a:r>
               <a:rPr lang="en-US" sz="3000" dirty="0"/>
               <a:t> </a:t>
             </a:r>
             <a:r>
-              <a:rPr lang="en-US" sz="3000"/>
-              <a:t>steering angle) </a:t>
-            </a:r>
-            <a:r>
-              <a:rPr lang="en-US" sz="3000" err="1"/>
+              <a:rPr lang="en-US" sz="3000" dirty="0" err="1"/>
+              <a:t>vozila</a:t>
+            </a:r>
+            <a:r>
+              <a:rPr lang="en-US" sz="3000" dirty="0"/>
+              <a:t> (</a:t>
+            </a:r>
+            <a:r>
+              <a:rPr lang="en-US" sz="3000" dirty="0" err="1"/>
+              <a:t>eng.</a:t>
+            </a:r>
+            <a:r>
+              <a:rPr lang="en-US" sz="3000" dirty="0"/>
+              <a:t> steering angle) </a:t>
+            </a:r>
+            <a:r>
+              <a:rPr lang="en-US" sz="3000" dirty="0" err="1"/>
               <a:t>i</a:t>
             </a:r>
             <a:r>
@@ -12482,7 +12482,7 @@
               <a:t> </a:t>
             </a:r>
             <a:r>
-              <a:rPr lang="en-US" sz="3000" err="1"/>
+              <a:rPr lang="en-US" sz="3000" dirty="0" err="1"/>
               <a:t>detektovanje</a:t>
             </a:r>
             <a:r>
@@ -12490,7 +12490,7 @@
               <a:t> </a:t>
             </a:r>
             <a:r>
-              <a:rPr lang="en-US" sz="3000" err="1"/>
+              <a:rPr lang="en-US" sz="3000" dirty="0" err="1"/>
               <a:t>promene</a:t>
             </a:r>
             <a:r>
@@ -12498,19 +12498,15 @@
               <a:t> </a:t>
             </a:r>
             <a:r>
-              <a:rPr lang="en-US" sz="3000" err="1"/>
+              <a:rPr lang="en-US" sz="3000" dirty="0" err="1"/>
               <a:t>trake</a:t>
             </a:r>
             <a:r>
               <a:rPr lang="en-US" sz="3000" dirty="0"/>
-              <a:t> </a:t>
-            </a:r>
-            <a:r>
-              <a:rPr lang="en-US" sz="3000"/>
-              <a:t>(</a:t>
-            </a:r>
-            <a:r>
-              <a:rPr lang="en-US" sz="3000" err="1"/>
+              <a:t> (</a:t>
+            </a:r>
+            <a:r>
+              <a:rPr lang="en-US" sz="3000" dirty="0" err="1"/>
               <a:t>eng.</a:t>
             </a:r>
             <a:r>
@@ -12620,7 +12616,7 @@
         </p:spPr>
         <p:txBody>
           <a:bodyPr vert="horz" lIns="91440" tIns="45720" rIns="91440" bIns="45720" rtlCol="0" anchor="t">
-            <a:normAutofit fontScale="92500" lnSpcReduction="20000"/>
+            <a:normAutofit lnSpcReduction="10000"/>
           </a:bodyPr>
           <a:lstStyle/>
           <a:p>
@@ -12723,7 +12719,7 @@
                 <a:ea typeface="+mn-lt"/>
                 <a:cs typeface="+mn-lt"/>
               </a:rPr>
-              <a:t>  </a:t>
+              <a:t> </a:t>
             </a:r>
             <a:r>
               <a:rPr lang="en-US" dirty="0" err="1">
@@ -12788,7 +12784,7 @@
               </a:rPr>
               <a:t>vozila</a:t>
             </a:r>
-            <a:endParaRPr lang="en-US" b="1" dirty="0" err="1"/>
+            <a:endParaRPr lang="en-US" b="1" dirty="0"/>
           </a:p>
           <a:p>
             <a:r>
@@ -12819,25 +12815,33 @@
               </a:rPr>
               <a:t>:</a:t>
             </a:r>
-            <a:endParaRPr lang="en-US" dirty="0" err="1"/>
-          </a:p>
-          <a:p>
-            <a:pPr marL="0" indent="0">
-              <a:buNone/>
-            </a:pPr>
+            <a:endParaRPr lang="sr-Latn-RS" b="1" dirty="0">
+              <a:ea typeface="+mn-lt"/>
+              <a:cs typeface="+mn-lt"/>
+            </a:endParaRPr>
+          </a:p>
+          <a:p>
+            <a:pPr lvl="1"/>
+            <a:r>
+              <a:rPr lang="en-US" dirty="0" err="1">
+                <a:ea typeface="+mn-lt"/>
+                <a:cs typeface="+mn-lt"/>
+              </a:rPr>
+              <a:t>jedna</a:t>
+            </a:r>
             <a:r>
               <a:rPr lang="en-US" dirty="0">
                 <a:ea typeface="+mn-lt"/>
                 <a:cs typeface="+mn-lt"/>
               </a:rPr>
-              <a:t>    -</a:t>
+              <a:t> </a:t>
             </a:r>
             <a:r>
               <a:rPr lang="en-US" dirty="0" err="1">
                 <a:ea typeface="+mn-lt"/>
                 <a:cs typeface="+mn-lt"/>
               </a:rPr>
-              <a:t>jedna</a:t>
+              <a:t>realna</a:t>
             </a:r>
             <a:r>
               <a:rPr lang="en-US" dirty="0">
@@ -12851,7 +12855,21 @@
                 <a:ea typeface="+mn-lt"/>
                 <a:cs typeface="+mn-lt"/>
               </a:rPr>
-              <a:t>realna</a:t>
+              <a:t>vrednost</a:t>
+            </a:r>
+            <a:endParaRPr lang="sr-Latn-RS" dirty="0">
+              <a:ea typeface="+mn-lt"/>
+              <a:cs typeface="+mn-lt"/>
+            </a:endParaRPr>
+          </a:p>
+          <a:p>
+            <a:pPr lvl="1"/>
+            <a:r>
+              <a:rPr lang="en-US" dirty="0" err="1">
+                <a:ea typeface="+mn-lt"/>
+                <a:cs typeface="+mn-lt"/>
+              </a:rPr>
+              <a:t>predstavlja</a:t>
             </a:r>
             <a:r>
               <a:rPr lang="en-US" dirty="0">
@@ -12865,33 +12883,128 @@
                 <a:ea typeface="+mn-lt"/>
                 <a:cs typeface="+mn-lt"/>
               </a:rPr>
-              <a:t>vrednost</a:t>
-            </a:r>
-            <a:endParaRPr lang="en-US"/>
-          </a:p>
-          <a:p>
-            <a:pPr marL="0" indent="0">
-              <a:buNone/>
-            </a:pPr>
+              <a:t>predviđeni</a:t>
+            </a:r>
             <a:r>
               <a:rPr lang="en-US" dirty="0">
                 <a:ea typeface="+mn-lt"/>
                 <a:cs typeface="+mn-lt"/>
               </a:rPr>
-              <a:t>    -</a:t>
-            </a:r>
+              <a:t> steering angle</a:t>
+            </a:r>
+            <a:endParaRPr lang="en-US" dirty="0"/>
+          </a:p>
+          <a:p>
             <a:r>
               <a:rPr lang="en-US" dirty="0" err="1">
                 <a:ea typeface="+mn-lt"/>
                 <a:cs typeface="+mn-lt"/>
               </a:rPr>
-              <a:t>predstavlja</a:t>
+              <a:t>Interpretacija</a:t>
             </a:r>
             <a:r>
               <a:rPr lang="en-US" dirty="0">
                 <a:ea typeface="+mn-lt"/>
                 <a:cs typeface="+mn-lt"/>
               </a:rPr>
+              <a:t>:</a:t>
+            </a:r>
+            <a:endParaRPr lang="sr-Latn-RS" dirty="0">
+              <a:ea typeface="+mn-lt"/>
+              <a:cs typeface="+mn-lt"/>
+            </a:endParaRPr>
+          </a:p>
+          <a:p>
+            <a:pPr lvl="1"/>
+            <a:r>
+              <a:rPr lang="en-US" dirty="0" err="1">
+                <a:ea typeface="+mn-lt"/>
+                <a:cs typeface="+mn-lt"/>
+              </a:rPr>
+              <a:t>ugao</a:t>
+            </a:r>
+            <a:r>
+              <a:rPr lang="en-US" dirty="0">
+                <a:ea typeface="+mn-lt"/>
+                <a:cs typeface="+mn-lt"/>
+              </a:rPr>
+              <a:t> ≈ 0 → </a:t>
+            </a:r>
+            <a:r>
+              <a:rPr lang="en-US" dirty="0" err="1">
+                <a:ea typeface="+mn-lt"/>
+                <a:cs typeface="+mn-lt"/>
+              </a:rPr>
+              <a:t>vozilo</a:t>
+            </a:r>
+            <a:r>
+              <a:rPr lang="en-US" dirty="0">
+                <a:ea typeface="+mn-lt"/>
+                <a:cs typeface="+mn-lt"/>
+              </a:rPr>
+              <a:t> ide </a:t>
+            </a:r>
+            <a:r>
+              <a:rPr lang="sr-Latn-RS" dirty="0">
+                <a:ea typeface="+mn-lt"/>
+                <a:cs typeface="+mn-lt"/>
+              </a:rPr>
+              <a:t>p</a:t>
+            </a:r>
+            <a:r>
+              <a:rPr lang="en-US" dirty="0">
+                <a:ea typeface="+mn-lt"/>
+                <a:cs typeface="+mn-lt"/>
+              </a:rPr>
+              <a:t>r</a:t>
+            </a:r>
+            <a:r>
+              <a:rPr lang="sr-Latn-RS" dirty="0">
+                <a:ea typeface="+mn-lt"/>
+                <a:cs typeface="+mn-lt"/>
+              </a:rPr>
+              <a:t>a</a:t>
+            </a:r>
+            <a:r>
+              <a:rPr lang="en-US" dirty="0" err="1">
+                <a:ea typeface="+mn-lt"/>
+                <a:cs typeface="+mn-lt"/>
+              </a:rPr>
+              <a:t>vo</a:t>
+            </a:r>
+            <a:endParaRPr lang="sr-Latn-RS" dirty="0">
+              <a:ea typeface="+mn-lt"/>
+              <a:cs typeface="+mn-lt"/>
+            </a:endParaRPr>
+          </a:p>
+          <a:p>
+            <a:pPr lvl="1"/>
+            <a:r>
+              <a:rPr lang="en-US" dirty="0" err="1">
+                <a:ea typeface="+mn-lt"/>
+                <a:cs typeface="+mn-lt"/>
+              </a:rPr>
+              <a:t>ugao</a:t>
+            </a:r>
+            <a:r>
+              <a:rPr lang="en-US" dirty="0">
+                <a:ea typeface="+mn-lt"/>
+                <a:cs typeface="+mn-lt"/>
+              </a:rPr>
+              <a:t> &gt; 0 → </a:t>
+            </a:r>
+            <a:r>
+              <a:rPr lang="en-US" dirty="0" err="1">
+                <a:ea typeface="+mn-lt"/>
+                <a:cs typeface="+mn-lt"/>
+              </a:rPr>
+              <a:t>skretanje</a:t>
+            </a:r>
+            <a:r>
+              <a:rPr lang="en-US" dirty="0">
+                <a:ea typeface="+mn-lt"/>
+                <a:cs typeface="+mn-lt"/>
+              </a:rPr>
               <a:t> </a:t>
             </a:r>
             <a:r>
@@ -12899,177 +13012,51 @@
                 <a:ea typeface="+mn-lt"/>
                 <a:cs typeface="+mn-lt"/>
               </a:rPr>
-              <a:t>predviđeni</a:t>
+              <a:t>ulevo</a:t>
+            </a:r>
+            <a:endParaRPr lang="sr-Latn-RS" dirty="0">
+              <a:ea typeface="+mn-lt"/>
+              <a:cs typeface="+mn-lt"/>
+            </a:endParaRPr>
+          </a:p>
+          <a:p>
+            <a:pPr lvl="1"/>
+            <a:r>
+              <a:rPr lang="en-US" dirty="0" err="1">
+                <a:ea typeface="+mn-lt"/>
+                <a:cs typeface="+mn-lt"/>
+              </a:rPr>
+              <a:t>ugao</a:t>
             </a:r>
             <a:r>
               <a:rPr lang="en-US" dirty="0">
                 <a:ea typeface="+mn-lt"/>
                 <a:cs typeface="+mn-lt"/>
               </a:rPr>
-              <a:t> steering angle</a:t>
+              <a:t> &lt; 0 → </a:t>
+            </a:r>
+            <a:r>
+              <a:rPr lang="en-US" dirty="0" err="1">
+                <a:ea typeface="+mn-lt"/>
+                <a:cs typeface="+mn-lt"/>
+              </a:rPr>
+              <a:t>skretanje</a:t>
+            </a:r>
+            <a:r>
+              <a:rPr lang="en-US" dirty="0">
+                <a:ea typeface="+mn-lt"/>
+                <a:cs typeface="+mn-lt"/>
+              </a:rPr>
+              <a:t> </a:t>
+            </a:r>
+            <a:r>
+              <a:rPr lang="en-US" dirty="0" err="1">
+                <a:ea typeface="+mn-lt"/>
+                <a:cs typeface="+mn-lt"/>
+              </a:rPr>
+              <a:t>udesno</a:t>
             </a:r>
             <a:endParaRPr lang="en-US" dirty="0"/>
-          </a:p>
-          <a:p>
-            <a:r>
-              <a:rPr lang="en-US" dirty="0" err="1">
-                <a:ea typeface="+mn-lt"/>
-                <a:cs typeface="+mn-lt"/>
-              </a:rPr>
-              <a:t>Interpretacija</a:t>
-            </a:r>
-            <a:r>
-              <a:rPr lang="en-US" dirty="0">
-                <a:ea typeface="+mn-lt"/>
-                <a:cs typeface="+mn-lt"/>
-              </a:rPr>
-              <a:t>:</a:t>
-            </a:r>
-            <a:endParaRPr lang="en-US" dirty="0"/>
-          </a:p>
-          <a:p>
-            <a:pPr marL="0" indent="0">
-              <a:buNone/>
-            </a:pPr>
-            <a:r>
-              <a:rPr lang="en-US" dirty="0">
-                <a:ea typeface="+mn-lt"/>
-                <a:cs typeface="+mn-lt"/>
-              </a:rPr>
-              <a:t>    - </a:t>
-            </a:r>
-            <a:r>
-              <a:rPr lang="en-US" dirty="0" err="1">
-                <a:ea typeface="+mn-lt"/>
-                <a:cs typeface="+mn-lt"/>
-              </a:rPr>
-              <a:t>ugao</a:t>
-            </a:r>
-            <a:r>
-              <a:rPr lang="en-US" dirty="0">
-                <a:ea typeface="+mn-lt"/>
-                <a:cs typeface="+mn-lt"/>
-              </a:rPr>
-              <a:t> ≈ 0 → </a:t>
-            </a:r>
-            <a:r>
-              <a:rPr lang="en-US" dirty="0" err="1">
-                <a:ea typeface="+mn-lt"/>
-                <a:cs typeface="+mn-lt"/>
-              </a:rPr>
-              <a:t>vozilo</a:t>
-            </a:r>
-            <a:r>
-              <a:rPr lang="en-US" dirty="0">
-                <a:ea typeface="+mn-lt"/>
-                <a:cs typeface="+mn-lt"/>
-              </a:rPr>
-              <a:t> ide </a:t>
-            </a:r>
-            <a:r>
-              <a:rPr lang="en-US" dirty="0" err="1">
-                <a:ea typeface="+mn-lt"/>
-                <a:cs typeface="+mn-lt"/>
-              </a:rPr>
-              <a:t>pravo</a:t>
-            </a:r>
-            <a:endParaRPr lang="en-US" dirty="0" err="1"/>
-          </a:p>
-          <a:p>
-            <a:pPr marL="0" indent="0">
-              <a:buNone/>
-            </a:pPr>
-            <a:r>
-              <a:rPr lang="en-US" dirty="0">
-                <a:ea typeface="+mn-lt"/>
-                <a:cs typeface="+mn-lt"/>
-              </a:rPr>
-              <a:t>    - </a:t>
-            </a:r>
-            <a:r>
-              <a:rPr lang="en-US" dirty="0" err="1">
-                <a:ea typeface="+mn-lt"/>
-                <a:cs typeface="+mn-lt"/>
-              </a:rPr>
-              <a:t>ugao</a:t>
-            </a:r>
-            <a:r>
-              <a:rPr lang="en-US" dirty="0">
-                <a:ea typeface="+mn-lt"/>
-                <a:cs typeface="+mn-lt"/>
-              </a:rPr>
-              <a:t> &gt; 0 → </a:t>
-            </a:r>
-            <a:r>
-              <a:rPr lang="en-US" dirty="0" err="1">
-                <a:ea typeface="+mn-lt"/>
-                <a:cs typeface="+mn-lt"/>
-              </a:rPr>
-              <a:t>skretanje</a:t>
-            </a:r>
-            <a:r>
-              <a:rPr lang="en-US" dirty="0">
-                <a:ea typeface="+mn-lt"/>
-                <a:cs typeface="+mn-lt"/>
-              </a:rPr>
-              <a:t> </a:t>
-            </a:r>
-            <a:r>
-              <a:rPr lang="en-US" dirty="0" err="1">
-                <a:ea typeface="+mn-lt"/>
-                <a:cs typeface="+mn-lt"/>
-              </a:rPr>
-              <a:t>ulevo</a:t>
-            </a:r>
-            <a:endParaRPr lang="en-US" dirty="0" err="1"/>
-          </a:p>
-          <a:p>
-            <a:pPr marL="0" indent="0">
-              <a:buNone/>
-            </a:pPr>
-            <a:r>
-              <a:rPr lang="en-US" dirty="0">
-                <a:ea typeface="+mn-lt"/>
-                <a:cs typeface="+mn-lt"/>
-              </a:rPr>
-              <a:t>    - </a:t>
-            </a:r>
-            <a:r>
-              <a:rPr lang="en-US" dirty="0" err="1">
-                <a:ea typeface="+mn-lt"/>
-                <a:cs typeface="+mn-lt"/>
-              </a:rPr>
-              <a:t>ugao</a:t>
-            </a:r>
-            <a:r>
-              <a:rPr lang="en-US" dirty="0">
-                <a:ea typeface="+mn-lt"/>
-                <a:cs typeface="+mn-lt"/>
-              </a:rPr>
-              <a:t> &lt; 0 → </a:t>
-            </a:r>
-            <a:r>
-              <a:rPr lang="en-US" dirty="0" err="1">
-                <a:ea typeface="+mn-lt"/>
-                <a:cs typeface="+mn-lt"/>
-              </a:rPr>
-              <a:t>skretanje</a:t>
-            </a:r>
-            <a:r>
-              <a:rPr lang="en-US" dirty="0">
-                <a:ea typeface="+mn-lt"/>
-                <a:cs typeface="+mn-lt"/>
-              </a:rPr>
-              <a:t> </a:t>
-            </a:r>
-            <a:r>
-              <a:rPr lang="en-US" dirty="0" err="1">
-                <a:ea typeface="+mn-lt"/>
-                <a:cs typeface="+mn-lt"/>
-              </a:rPr>
-              <a:t>udesno</a:t>
-            </a:r>
-            <a:endParaRPr lang="en-US" dirty="0" err="1"/>
           </a:p>
           <a:p>
             <a:endParaRPr lang="en-US" dirty="0"/>
@@ -13227,65 +13214,176 @@
               </a:rPr>
               <a:t>:</a:t>
             </a:r>
+            <a:endParaRPr lang="sr-Latn-RS" dirty="0">
+              <a:ea typeface="+mn-lt"/>
+              <a:cs typeface="+mn-lt"/>
+            </a:endParaRPr>
+          </a:p>
+          <a:p>
+            <a:pPr marL="800100" lvl="1" indent="-342900"/>
+            <a:r>
+              <a:rPr lang="en-US" dirty="0" err="1">
+                <a:ea typeface="+mn-lt"/>
+                <a:cs typeface="+mn-lt"/>
+              </a:rPr>
+              <a:t>primenjuje</a:t>
+            </a:r>
+            <a:r>
+              <a:rPr lang="en-US" dirty="0">
+                <a:ea typeface="+mn-lt"/>
+                <a:cs typeface="+mn-lt"/>
+              </a:rPr>
+              <a:t> se </a:t>
+            </a:r>
+            <a:r>
+              <a:rPr lang="en-US" i="1" dirty="0">
+                <a:ea typeface="+mn-lt"/>
+                <a:cs typeface="+mn-lt"/>
+              </a:rPr>
+              <a:t>moving average smoothing</a:t>
+            </a:r>
+            <a:endParaRPr lang="sr-Latn-RS" i="1" dirty="0">
+              <a:ea typeface="+mn-lt"/>
+              <a:cs typeface="+mn-lt"/>
+            </a:endParaRPr>
+          </a:p>
+          <a:p>
+            <a:pPr marL="800100" lvl="1" indent="-342900"/>
+            <a:r>
+              <a:rPr lang="en-US" dirty="0" err="1">
+                <a:ea typeface="+mn-lt"/>
+                <a:cs typeface="+mn-lt"/>
+              </a:rPr>
+              <a:t>smanjuje</a:t>
+            </a:r>
+            <a:r>
+              <a:rPr lang="en-US" dirty="0">
+                <a:ea typeface="+mn-lt"/>
+                <a:cs typeface="+mn-lt"/>
+              </a:rPr>
+              <a:t> </a:t>
+            </a:r>
+            <a:r>
+              <a:rPr lang="en-US" dirty="0" err="1">
+                <a:ea typeface="+mn-lt"/>
+                <a:cs typeface="+mn-lt"/>
+              </a:rPr>
+              <a:t>šum</a:t>
+            </a:r>
+            <a:r>
+              <a:rPr lang="en-US" dirty="0">
+                <a:ea typeface="+mn-lt"/>
+                <a:cs typeface="+mn-lt"/>
+              </a:rPr>
+              <a:t> u </a:t>
+            </a:r>
+            <a:r>
+              <a:rPr lang="en-US" dirty="0" err="1">
+                <a:ea typeface="+mn-lt"/>
+                <a:cs typeface="+mn-lt"/>
+              </a:rPr>
+              <a:t>predikcijama</a:t>
+            </a:r>
             <a:endParaRPr lang="en-US" dirty="0"/>
           </a:p>
           <a:p>
-            <a:pPr marL="0" indent="0">
-              <a:buNone/>
-            </a:pPr>
+            <a:pPr marL="342900" indent="-342900"/>
             <a:r>
               <a:rPr lang="en-US" dirty="0">
                 <a:ea typeface="+mn-lt"/>
                 <a:cs typeface="+mn-lt"/>
               </a:rPr>
-              <a:t>  - </a:t>
+              <a:t> </a:t>
             </a:r>
             <a:r>
               <a:rPr lang="en-US" dirty="0" err="1">
                 <a:ea typeface="+mn-lt"/>
                 <a:cs typeface="+mn-lt"/>
               </a:rPr>
-              <a:t>primenjuje</a:t>
+              <a:t>Definisanje</a:t>
             </a:r>
             <a:r>
               <a:rPr lang="en-US" dirty="0">
                 <a:ea typeface="+mn-lt"/>
                 <a:cs typeface="+mn-lt"/>
               </a:rPr>
-              <a:t> se </a:t>
-            </a:r>
-            <a:r>
-              <a:rPr lang="en-US" i="1" dirty="0">
-                <a:ea typeface="+mn-lt"/>
-                <a:cs typeface="+mn-lt"/>
-              </a:rPr>
-              <a:t>moving average smoothing</a:t>
-            </a:r>
-            <a:endParaRPr lang="en-US" dirty="0"/>
-          </a:p>
-          <a:p>
-            <a:pPr marL="0" indent="0">
-              <a:buNone/>
-            </a:pPr>
+              <a:t> </a:t>
+            </a:r>
+            <a:r>
+              <a:rPr lang="en-US" dirty="0" err="1">
+                <a:ea typeface="+mn-lt"/>
+                <a:cs typeface="+mn-lt"/>
+              </a:rPr>
+              <a:t>pragova</a:t>
+            </a:r>
+            <a:endParaRPr lang="sr-Latn-RS" dirty="0">
+              <a:ea typeface="+mn-lt"/>
+              <a:cs typeface="+mn-lt"/>
+            </a:endParaRPr>
+          </a:p>
+          <a:p>
+            <a:pPr marL="800100" lvl="1" indent="-342900"/>
             <a:r>
               <a:rPr lang="en-US" dirty="0">
                 <a:ea typeface="+mn-lt"/>
                 <a:cs typeface="+mn-lt"/>
               </a:rPr>
-              <a:t>  - </a:t>
+              <a:t>center threshold – </a:t>
             </a:r>
             <a:r>
               <a:rPr lang="en-US" dirty="0" err="1">
                 <a:ea typeface="+mn-lt"/>
                 <a:cs typeface="+mn-lt"/>
               </a:rPr>
-              <a:t>smanjuje</a:t>
+              <a:t>vozilo</a:t>
             </a:r>
             <a:r>
               <a:rPr lang="en-US" dirty="0">
                 <a:ea typeface="+mn-lt"/>
                 <a:cs typeface="+mn-lt"/>
               </a:rPr>
+              <a:t> ide pr</a:t>
+            </a:r>
+            <a:r>
+              <a:rPr lang="sr-Latn-RS" dirty="0">
+                <a:ea typeface="+mn-lt"/>
+                <a:cs typeface="+mn-lt"/>
+              </a:rPr>
+              <a:t>a</a:t>
+            </a:r>
+            <a:r>
+              <a:rPr lang="en-US" dirty="0" err="1">
+                <a:ea typeface="+mn-lt"/>
+                <a:cs typeface="+mn-lt"/>
+              </a:rPr>
+              <a:t>vo</a:t>
+            </a:r>
+            <a:endParaRPr lang="sr-Latn-RS" dirty="0">
+              <a:ea typeface="+mn-lt"/>
+              <a:cs typeface="+mn-lt"/>
+            </a:endParaRPr>
+          </a:p>
+          <a:p>
+            <a:pPr marL="800100" lvl="1" indent="-342900"/>
+            <a:r>
+              <a:rPr lang="en-US" dirty="0">
+                <a:ea typeface="+mn-lt"/>
+                <a:cs typeface="+mn-lt"/>
+              </a:rPr>
+              <a:t>lane threshold – </a:t>
+            </a:r>
+            <a:r>
+              <a:rPr lang="en-US" dirty="0" err="1">
+                <a:ea typeface="+mn-lt"/>
+                <a:cs typeface="+mn-lt"/>
+              </a:rPr>
+              <a:t>vozilo</a:t>
+            </a:r>
+            <a:r>
+              <a:rPr lang="en-US" dirty="0">
+                <a:ea typeface="+mn-lt"/>
+                <a:cs typeface="+mn-lt"/>
+              </a:rPr>
               <a:t> </a:t>
             </a:r>
             <a:r>
@@ -13293,155 +13391,36 @@
                 <a:ea typeface="+mn-lt"/>
                 <a:cs typeface="+mn-lt"/>
               </a:rPr>
-              <a:t>šum</a:t>
+              <a:t>započinje</a:t>
             </a:r>
             <a:r>
               <a:rPr lang="en-US" dirty="0">
                 <a:ea typeface="+mn-lt"/>
                 <a:cs typeface="+mn-lt"/>
               </a:rPr>
-              <a:t> u </a:t>
+              <a:t> </a:t>
             </a:r>
             <a:r>
               <a:rPr lang="en-US" dirty="0" err="1">
                 <a:ea typeface="+mn-lt"/>
                 <a:cs typeface="+mn-lt"/>
               </a:rPr>
-              <a:t>predikcijama</a:t>
-            </a:r>
-          </a:p>
-          <a:p>
-            <a:pPr marL="342900" indent="-342900"/>
+              <a:t>promenu</a:t>
+            </a:r>
             <a:r>
               <a:rPr lang="en-US" dirty="0">
                 <a:ea typeface="+mn-lt"/>
                 <a:cs typeface="+mn-lt"/>
               </a:rPr>
-              <a:t> </a:t>
+              <a:t> </a:t>
             </a:r>
             <a:r>
               <a:rPr lang="en-US" dirty="0" err="1">
                 <a:ea typeface="+mn-lt"/>
                 <a:cs typeface="+mn-lt"/>
               </a:rPr>
-              <a:t>Definisanje</a:t>
-            </a:r>
-            <a:r>
-              <a:rPr lang="en-US" dirty="0">
-                <a:ea typeface="+mn-lt"/>
-                <a:cs typeface="+mn-lt"/>
-              </a:rPr>
-              <a:t> </a:t>
-            </a:r>
-            <a:r>
-              <a:rPr lang="en-US" dirty="0" err="1">
-                <a:ea typeface="+mn-lt"/>
-                <a:cs typeface="+mn-lt"/>
-              </a:rPr>
-              <a:t>pragova</a:t>
-            </a:r>
-            <a:endParaRPr lang="en-US" dirty="0" err="1"/>
-          </a:p>
-          <a:p>
-            <a:pPr marL="0" indent="0">
-              <a:buNone/>
-            </a:pPr>
-            <a:r>
-              <a:rPr lang="en-US" dirty="0">
-                <a:ea typeface="+mn-lt"/>
-                <a:cs typeface="+mn-lt"/>
-              </a:rPr>
-              <a:t>  - center threshold – </a:t>
-            </a:r>
-            <a:r>
-              <a:rPr lang="en-US" dirty="0" err="1">
-                <a:ea typeface="+mn-lt"/>
-                <a:cs typeface="+mn-lt"/>
-              </a:rPr>
-              <a:t>vozilo</a:t>
-            </a:r>
-            <a:r>
-              <a:rPr lang="en-US" dirty="0">
-                <a:ea typeface="+mn-lt"/>
-                <a:cs typeface="+mn-lt"/>
-              </a:rPr>
-              <a:t> ide </a:t>
-            </a:r>
-            <a:r>
-              <a:rPr lang="en-US" dirty="0" err="1">
-                <a:ea typeface="+mn-lt"/>
-                <a:cs typeface="+mn-lt"/>
-              </a:rPr>
-              <a:t>pravo</a:t>
-            </a:r>
-            <a:endParaRPr lang="en-US" dirty="0" err="1"/>
-          </a:p>
-          <a:p>
-            <a:pPr marL="0" indent="0">
-              <a:buNone/>
-            </a:pPr>
-            <a:r>
-              <a:rPr lang="en-US" dirty="0">
-                <a:ea typeface="+mn-lt"/>
-                <a:cs typeface="+mn-lt"/>
-              </a:rPr>
-              <a:t>  - lane threshold – </a:t>
-            </a:r>
-            <a:r>
-              <a:rPr lang="en-US" dirty="0" err="1">
-                <a:ea typeface="+mn-lt"/>
-                <a:cs typeface="+mn-lt"/>
-              </a:rPr>
-              <a:t>vozilo</a:t>
-            </a:r>
-            <a:r>
-              <a:rPr lang="en-US" dirty="0">
-                <a:ea typeface="+mn-lt"/>
-                <a:cs typeface="+mn-lt"/>
-              </a:rPr>
-              <a:t> </a:t>
-            </a:r>
-            <a:r>
-              <a:rPr lang="en-US" dirty="0" err="1">
-                <a:ea typeface="+mn-lt"/>
-                <a:cs typeface="+mn-lt"/>
-              </a:rPr>
-              <a:t>započinje</a:t>
-            </a:r>
-            <a:r>
-              <a:rPr lang="en-US" dirty="0">
-                <a:ea typeface="+mn-lt"/>
-                <a:cs typeface="+mn-lt"/>
-              </a:rPr>
-              <a:t> </a:t>
-            </a:r>
-            <a:r>
-              <a:rPr lang="en-US" dirty="0" err="1">
-                <a:ea typeface="+mn-lt"/>
-                <a:cs typeface="+mn-lt"/>
-              </a:rPr>
-              <a:t>promenu</a:t>
-            </a:r>
-            <a:r>
-              <a:rPr lang="en-US" dirty="0">
-                <a:ea typeface="+mn-lt"/>
-                <a:cs typeface="+mn-lt"/>
-              </a:rPr>
-              <a:t> </a:t>
-            </a:r>
-            <a:r>
-              <a:rPr lang="en-US" dirty="0" err="1">
-                <a:ea typeface="+mn-lt"/>
-                <a:cs typeface="+mn-lt"/>
-              </a:rPr>
               <a:t>trake</a:t>
             </a:r>
-            <a:endParaRPr lang="en-US" dirty="0" err="1"/>
-          </a:p>
-          <a:p>
-            <a:pPr marL="0" indent="0">
-              <a:buNone/>
-            </a:pPr>
             <a:endParaRPr lang="en-US" dirty="0"/>
           </a:p>
           <a:p>
@@ -13583,90 +13562,87 @@
               </a:rPr>
               <a:t>:</a:t>
             </a:r>
-            <a:endParaRPr lang="en-US" sz="2200"/>
-          </a:p>
-          <a:p>
-            <a:pPr marL="0" indent="0">
-              <a:buNone/>
-            </a:pPr>
-            <a:r>
-              <a:rPr lang="en-US" sz="2200" dirty="0">
-                <a:ea typeface="+mn-lt"/>
-                <a:cs typeface="+mn-lt"/>
-              </a:rPr>
-              <a:t>  -|angle| &lt; </a:t>
-            </a:r>
-            <a:r>
-              <a:rPr lang="en-US" sz="2200" dirty="0" err="1">
+            <a:endParaRPr lang="sr-Latn-RS" sz="2200" dirty="0">
+              <a:ea typeface="+mn-lt"/>
+              <a:cs typeface="+mn-lt"/>
+            </a:endParaRPr>
+          </a:p>
+          <a:p>
+            <a:pPr lvl="1"/>
+            <a:r>
+              <a:rPr lang="en-US" sz="1800" dirty="0">
+                <a:ea typeface="+mn-lt"/>
+                <a:cs typeface="+mn-lt"/>
+              </a:rPr>
+              <a:t>|angle| &lt; </a:t>
+            </a:r>
+            <a:r>
+              <a:rPr lang="en-US" sz="1800" dirty="0" err="1">
                 <a:ea typeface="+mn-lt"/>
                 <a:cs typeface="+mn-lt"/>
               </a:rPr>
               <a:t>center_threshold</a:t>
             </a:r>
             <a:r>
-              <a:rPr lang="en-US" sz="2200" dirty="0">
+              <a:rPr lang="en-US" sz="1800" dirty="0">
                 <a:ea typeface="+mn-lt"/>
                 <a:cs typeface="+mn-lt"/>
               </a:rPr>
               <a:t> → CENTER</a:t>
             </a:r>
-            <a:endParaRPr lang="en-US" sz="2200"/>
-          </a:p>
-          <a:p>
-            <a:pPr marL="0" indent="0">
-              <a:buNone/>
-            </a:pPr>
-            <a:r>
-              <a:rPr lang="en-US" sz="2200" dirty="0">
-                <a:ea typeface="+mn-lt"/>
-                <a:cs typeface="+mn-lt"/>
-              </a:rPr>
-              <a:t>  - angle &gt; </a:t>
-            </a:r>
-            <a:r>
-              <a:rPr lang="en-US" sz="2200" dirty="0" err="1">
+            <a:endParaRPr lang="en-US" sz="1800" dirty="0"/>
+          </a:p>
+          <a:p>
+            <a:pPr lvl="1"/>
+            <a:r>
+              <a:rPr lang="en-US" sz="1800" dirty="0">
+                <a:ea typeface="+mn-lt"/>
+                <a:cs typeface="+mn-lt"/>
+              </a:rPr>
+              <a:t>angle &gt; </a:t>
+            </a:r>
+            <a:r>
+              <a:rPr lang="en-US" sz="1800" dirty="0" err="1">
                 <a:ea typeface="+mn-lt"/>
                 <a:cs typeface="+mn-lt"/>
               </a:rPr>
               <a:t>lane_threshold</a:t>
             </a:r>
             <a:r>
-              <a:rPr lang="en-US" sz="2200" dirty="0">
+              <a:rPr lang="en-US" sz="1800" dirty="0">
                 <a:ea typeface="+mn-lt"/>
                 <a:cs typeface="+mn-lt"/>
               </a:rPr>
               <a:t> → LEFT lane change</a:t>
             </a:r>
-            <a:endParaRPr lang="en-US" sz="2200"/>
-          </a:p>
-          <a:p>
-            <a:pPr marL="0" indent="0">
-              <a:buNone/>
-            </a:pPr>
-            <a:r>
-              <a:rPr lang="en-US" sz="2200" dirty="0">
-                <a:ea typeface="+mn-lt"/>
-                <a:cs typeface="+mn-lt"/>
-              </a:rPr>
-              <a:t>  - angle &lt; -</a:t>
-            </a:r>
-            <a:r>
-              <a:rPr lang="en-US" sz="2200" dirty="0" err="1">
+            <a:endParaRPr lang="sr-Latn-RS" sz="1800" dirty="0">
+              <a:ea typeface="+mn-lt"/>
+              <a:cs typeface="+mn-lt"/>
+            </a:endParaRPr>
+          </a:p>
+          <a:p>
+            <a:pPr lvl="1"/>
+            <a:r>
+              <a:rPr lang="en-US" sz="1800" dirty="0">
+                <a:ea typeface="+mn-lt"/>
+                <a:cs typeface="+mn-lt"/>
+              </a:rPr>
+              <a:t>angle &lt; -</a:t>
+            </a:r>
+            <a:r>
+              <a:rPr lang="en-US" sz="1800" dirty="0" err="1">
                 <a:ea typeface="+mn-lt"/>
                 <a:cs typeface="+mn-lt"/>
               </a:rPr>
               <a:t>lane_threshold</a:t>
             </a:r>
             <a:r>
-              <a:rPr lang="en-US" sz="2200" dirty="0">
+              <a:rPr lang="en-US" sz="1800" dirty="0">
                 <a:ea typeface="+mn-lt"/>
                 <a:cs typeface="+mn-lt"/>
               </a:rPr>
               <a:t> → RIGHT lane change</a:t>
             </a:r>
-            <a:endParaRPr lang="en-US" sz="2200"/>
-          </a:p>
-          <a:p>
             <a:endParaRPr lang="en-US" sz="2200" dirty="0">
               <a:ea typeface="+mn-lt"/>
               <a:cs typeface="+mn-lt"/>
@@ -13674,14 +13650,14 @@
           </a:p>
           <a:p>
             <a:r>
-              <a:rPr lang="en-US" sz="2200">
+              <a:rPr lang="en-US" sz="2200" dirty="0">
                 <a:ea typeface="+mn-lt"/>
                 <a:cs typeface="+mn-lt"/>
               </a:rPr>
               <a:t>Da bi se </a:t>
             </a:r>
             <a:r>
-              <a:rPr lang="en-US" sz="2200" err="1">
+              <a:rPr lang="en-US" sz="2200" dirty="0" err="1">
                 <a:ea typeface="+mn-lt"/>
                 <a:cs typeface="+mn-lt"/>
               </a:rPr>
@@ -13695,7 +13671,7 @@
               <a:t> </a:t>
             </a:r>
             <a:r>
-              <a:rPr lang="en-US" sz="2200" err="1">
+              <a:rPr lang="en-US" sz="2200" dirty="0" err="1">
                 <a:ea typeface="+mn-lt"/>
                 <a:cs typeface="+mn-lt"/>
               </a:rPr>
@@ -13709,7 +13685,7 @@
               <a:t> </a:t>
             </a:r>
             <a:r>
-              <a:rPr lang="en-US" sz="2200" err="1">
+              <a:rPr lang="en-US" sz="2200" dirty="0" err="1">
                 <a:ea typeface="+mn-lt"/>
                 <a:cs typeface="+mn-lt"/>
               </a:rPr>
@@ -13723,7 +13699,7 @@
               <a:t> signal mora </a:t>
             </a:r>
             <a:r>
-              <a:rPr lang="en-US" sz="2200" err="1">
+              <a:rPr lang="en-US" sz="2200" dirty="0" err="1">
                 <a:ea typeface="+mn-lt"/>
                 <a:cs typeface="+mn-lt"/>
               </a:rPr>
@@ -13737,7 +13713,7 @@
               <a:t> </a:t>
             </a:r>
             <a:r>
-              <a:rPr lang="en-US" sz="2200" err="1">
+              <a:rPr lang="en-US" sz="2200" dirty="0" err="1">
                 <a:ea typeface="+mn-lt"/>
                 <a:cs typeface="+mn-lt"/>
               </a:rPr>
@@ -13751,13 +13727,13 @@
               <a:t> </a:t>
             </a:r>
             <a:r>
-              <a:rPr lang="en-US" sz="2200" err="1">
+              <a:rPr lang="en-US" sz="2200" dirty="0" err="1">
                 <a:ea typeface="+mn-lt"/>
                 <a:cs typeface="+mn-lt"/>
               </a:rPr>
               <a:t>frejmova</a:t>
             </a:r>
-            <a:endParaRPr lang="en-US" sz="2200"/>
+            <a:endParaRPr lang="en-US" sz="2200" dirty="0"/>
           </a:p>
           <a:p>
             <a:r>
@@ -14010,31 +13986,82 @@
               </a:rPr>
               <a:t>:</a:t>
             </a:r>
-            <a:endParaRPr lang="en-US"/>
-          </a:p>
-          <a:p>
-            <a:pPr marL="0" indent="0">
-              <a:buNone/>
-            </a:pPr>
+            <a:endParaRPr lang="sr-Latn-RS" dirty="0">
+              <a:ea typeface="+mn-lt"/>
+              <a:cs typeface="+mn-lt"/>
+            </a:endParaRPr>
+          </a:p>
+          <a:p>
+            <a:pPr lvl="1"/>
+            <a:r>
+              <a:rPr lang="en-US" dirty="0" err="1">
+                <a:ea typeface="+mn-lt"/>
+                <a:cs typeface="+mn-lt"/>
+              </a:rPr>
+              <a:t>originalne</a:t>
+            </a:r>
             <a:r>
               <a:rPr lang="en-US" dirty="0">
                 <a:ea typeface="+mn-lt"/>
                 <a:cs typeface="+mn-lt"/>
               </a:rPr>
-              <a:t>-</a:t>
+              <a:t> </a:t>
             </a:r>
             <a:r>
               <a:rPr lang="en-US" dirty="0" err="1">
                 <a:ea typeface="+mn-lt"/>
                 <a:cs typeface="+mn-lt"/>
               </a:rPr>
-              <a:t>originalne</a:t>
+              <a:t>slike</a:t>
+            </a:r>
+            <a:endParaRPr lang="en-US" dirty="0"/>
+          </a:p>
+          <a:p>
+            <a:pPr lvl="1"/>
+            <a:r>
+              <a:rPr lang="en-US" dirty="0" err="1">
+                <a:ea typeface="+mn-lt"/>
+                <a:cs typeface="+mn-lt"/>
+              </a:rPr>
+              <a:t>predviđeni</a:t>
             </a:r>
             <a:r>
               <a:rPr lang="en-US" dirty="0">
                 <a:ea typeface="+mn-lt"/>
                 <a:cs typeface="+mn-lt"/>
               </a:rPr>
+              <a:t> steering angle</a:t>
+            </a:r>
+            <a:endParaRPr lang="en-US" dirty="0"/>
+          </a:p>
+          <a:p>
+            <a:pPr lvl="1"/>
+            <a:r>
+              <a:rPr lang="en-US" dirty="0" err="1">
+                <a:ea typeface="+mn-lt"/>
+                <a:cs typeface="+mn-lt"/>
+              </a:rPr>
+              <a:t>upozorenje</a:t>
+            </a:r>
+            <a:r>
+              <a:rPr lang="en-US" dirty="0">
+                <a:ea typeface="+mn-lt"/>
+                <a:cs typeface="+mn-lt"/>
+              </a:rPr>
+              <a:t> za </a:t>
+            </a:r>
+            <a:r>
+              <a:rPr lang="en-US" dirty="0" err="1">
+                <a:ea typeface="+mn-lt"/>
+                <a:cs typeface="+mn-lt"/>
+              </a:rPr>
+              <a:t>promenu</a:t>
+            </a:r>
+            <a:r>
+              <a:rPr lang="en-US" dirty="0">
+                <a:ea typeface="+mn-lt"/>
+                <a:cs typeface="+mn-lt"/>
+              </a:rPr>
               <a:t> </a:t>
             </a:r>
             <a:r>
@@ -14042,148 +14069,66 @@
                 <a:ea typeface="+mn-lt"/>
                 <a:cs typeface="+mn-lt"/>
               </a:rPr>
-              <a:t>slike</a:t>
+              <a:t>trake</a:t>
             </a:r>
             <a:endParaRPr lang="en-US" dirty="0"/>
           </a:p>
           <a:p>
-            <a:pPr marL="0" indent="0">
-              <a:buNone/>
-            </a:pPr>
             <a:r>
               <a:rPr lang="en-US" dirty="0">
                 <a:ea typeface="+mn-lt"/>
                 <a:cs typeface="+mn-lt"/>
               </a:rPr>
-              <a:t>-</a:t>
+              <a:t>Video se </a:t>
             </a:r>
             <a:r>
               <a:rPr lang="en-US" dirty="0" err="1">
                 <a:ea typeface="+mn-lt"/>
                 <a:cs typeface="+mn-lt"/>
               </a:rPr>
-              <a:t>predviđeni</a:t>
+              <a:t>generiše</a:t>
             </a:r>
             <a:r>
               <a:rPr lang="en-US" dirty="0">
                 <a:ea typeface="+mn-lt"/>
                 <a:cs typeface="+mn-lt"/>
               </a:rPr>
-              <a:t> steering angle</a:t>
-            </a:r>
-            <a:endParaRPr lang="en-US" dirty="0"/>
-          </a:p>
-          <a:p>
-            <a:pPr marL="0" indent="0">
-              <a:buNone/>
-            </a:pPr>
+              <a:t> </a:t>
+            </a:r>
+            <a:r>
+              <a:rPr lang="en-US" dirty="0" err="1">
+                <a:ea typeface="+mn-lt"/>
+                <a:cs typeface="+mn-lt"/>
+              </a:rPr>
+              <a:t>iz</a:t>
+            </a:r>
             <a:r>
               <a:rPr lang="en-US" dirty="0">
                 <a:ea typeface="+mn-lt"/>
                 <a:cs typeface="+mn-lt"/>
               </a:rPr>
-              <a:t>-</a:t>
+              <a:t> test </a:t>
             </a:r>
             <a:r>
               <a:rPr lang="en-US" dirty="0" err="1">
                 <a:ea typeface="+mn-lt"/>
                 <a:cs typeface="+mn-lt"/>
               </a:rPr>
-              <a:t>upozorenje</a:t>
+              <a:t>skupa</a:t>
             </a:r>
             <a:r>
               <a:rPr lang="en-US" dirty="0">
                 <a:ea typeface="+mn-lt"/>
                 <a:cs typeface="+mn-lt"/>
               </a:rPr>
-              <a:t> za </a:t>
+              <a:t> </a:t>
             </a:r>
             <a:r>
               <a:rPr lang="en-US" dirty="0" err="1">
                 <a:ea typeface="+mn-lt"/>
                 <a:cs typeface="+mn-lt"/>
               </a:rPr>
-              <a:t>promenu</a:t>
-            </a:r>
-            <a:r>
-              <a:rPr lang="en-US" dirty="0">
-                <a:ea typeface="+mn-lt"/>
-                <a:cs typeface="+mn-lt"/>
-              </a:rPr>
-              <a:t> </a:t>
-            </a:r>
-            <a:r>
-              <a:rPr lang="en-US" dirty="0" err="1">
-                <a:ea typeface="+mn-lt"/>
-                <a:cs typeface="+mn-lt"/>
-              </a:rPr>
-              <a:t>trake</a:t>
-            </a:r>
-            <a:endParaRPr lang="en-US" dirty="0"/>
-          </a:p>
-          <a:p>
-            <a:r>
-              <a:rPr lang="en-US" dirty="0">
-                <a:ea typeface="+mn-lt"/>
-                <a:cs typeface="+mn-lt"/>
-              </a:rPr>
-              <a:t>Video se </a:t>
-            </a:r>
-            <a:r>
-              <a:rPr lang="en-US" dirty="0" err="1">
-                <a:ea typeface="+mn-lt"/>
-                <a:cs typeface="+mn-lt"/>
-              </a:rPr>
-              <a:t>generiše</a:t>
-            </a:r>
-            <a:r>
-              <a:rPr lang="en-US" dirty="0">
-                <a:ea typeface="+mn-lt"/>
-                <a:cs typeface="+mn-lt"/>
-              </a:rPr>
-              <a:t> </a:t>
-            </a:r>
-            <a:r>
-              <a:rPr lang="en-US" dirty="0" err="1">
-                <a:ea typeface="+mn-lt"/>
-                <a:cs typeface="+mn-lt"/>
-              </a:rPr>
-              <a:t>iz</a:t>
-            </a:r>
-            <a:r>
-              <a:rPr lang="en-US" dirty="0">
-                <a:ea typeface="+mn-lt"/>
-                <a:cs typeface="+mn-lt"/>
-              </a:rPr>
-              <a:t> test </a:t>
-            </a:r>
-            <a:r>
-              <a:rPr lang="en-US" dirty="0" err="1">
-                <a:ea typeface="+mn-lt"/>
-                <a:cs typeface="+mn-lt"/>
-              </a:rPr>
-              <a:t>skupa</a:t>
-            </a:r>
-            <a:r>
-              <a:rPr lang="en-US" dirty="0">
-                <a:ea typeface="+mn-lt"/>
-                <a:cs typeface="+mn-lt"/>
-              </a:rPr>
-              <a:t> </a:t>
-            </a:r>
-            <a:r>
-              <a:rPr lang="en-US" dirty="0" err="1">
-                <a:ea typeface="+mn-lt"/>
-                <a:cs typeface="+mn-lt"/>
-              </a:rPr>
               <a:t>podataka</a:t>
-            </a:r>
-            <a:r>
-              <a:rPr lang="en-US" dirty="0">
-                <a:ea typeface="+mn-lt"/>
-                <a:cs typeface="+mn-lt"/>
-              </a:rPr>
-              <a:t>.</a:t>
             </a:r>
             <a:endParaRPr lang="en-US" dirty="0"/>
           </a:p>
@@ -14630,7 +14575,7 @@
           <a:lstStyle/>
           <a:p>
             <a:r>
-              <a:rPr lang="en-US" err="1"/>
+              <a:rPr lang="en-US" dirty="0" err="1"/>
               <a:t>Praćenje</a:t>
             </a:r>
             <a:r>
@@ -14638,11 +14583,11 @@
               <a:t> </a:t>
             </a:r>
             <a:r>
-              <a:rPr lang="en-US" err="1"/>
+              <a:rPr lang="en-US" dirty="0" err="1"/>
               <a:t>metrike</a:t>
             </a:r>
             <a:r>
-              <a:rPr lang="en-US"/>
+              <a:rPr lang="en-US" dirty="0"/>
               <a:t>: MSE, MAE I Validation loss</a:t>
             </a:r>
           </a:p>
@@ -14690,31 +14635,110 @@
               <a:rPr lang="en-US" dirty="0"/>
               <a:t>: </a:t>
             </a:r>
-            <a:endParaRPr lang="en-US" dirty="0">
+            <a:endParaRPr lang="sr-Latn-RS" dirty="0"/>
+          </a:p>
+          <a:p>
+            <a:pPr lvl="1"/>
+            <a:r>
+              <a:rPr lang="en-US" dirty="0" err="1">
+                <a:ea typeface="+mn-lt"/>
+                <a:cs typeface="+mn-lt"/>
+              </a:rPr>
+              <a:t>Treniranje</a:t>
+            </a:r>
+            <a:r>
+              <a:rPr lang="en-US" dirty="0">
+                <a:ea typeface="+mn-lt"/>
+                <a:cs typeface="+mn-lt"/>
+              </a:rPr>
+              <a:t> </a:t>
+            </a:r>
+            <a:r>
+              <a:rPr lang="en-US" dirty="0" err="1">
+                <a:ea typeface="+mn-lt"/>
+                <a:cs typeface="+mn-lt"/>
+              </a:rPr>
+              <a:t>modela</a:t>
+            </a:r>
+            <a:r>
+              <a:rPr lang="en-US" dirty="0">
+                <a:ea typeface="+mn-lt"/>
+                <a:cs typeface="+mn-lt"/>
+              </a:rPr>
+              <a:t> </a:t>
+            </a:r>
+            <a:r>
+              <a:rPr lang="en-US" dirty="0" err="1">
+                <a:ea typeface="+mn-lt"/>
+                <a:cs typeface="+mn-lt"/>
+              </a:rPr>
+              <a:t>kroz</a:t>
+            </a:r>
+            <a:r>
+              <a:rPr lang="en-US" dirty="0">
+                <a:ea typeface="+mn-lt"/>
+                <a:cs typeface="+mn-lt"/>
+              </a:rPr>
+              <a:t> </a:t>
+            </a:r>
+            <a:r>
+              <a:rPr lang="en-US" dirty="0" err="1">
+                <a:ea typeface="+mn-lt"/>
+                <a:cs typeface="+mn-lt"/>
+              </a:rPr>
+              <a:t>više</a:t>
+            </a:r>
+            <a:r>
+              <a:rPr lang="en-US" dirty="0">
+                <a:ea typeface="+mn-lt"/>
+                <a:cs typeface="+mn-lt"/>
+              </a:rPr>
+              <a:t> </a:t>
+            </a:r>
+            <a:r>
+              <a:rPr lang="en-US" dirty="0" err="1">
+                <a:ea typeface="+mn-lt"/>
+                <a:cs typeface="+mn-lt"/>
+              </a:rPr>
+              <a:t>epoha</a:t>
+            </a:r>
+            <a:endParaRPr lang="sr-Latn-RS" dirty="0">
               <a:ea typeface="+mn-lt"/>
               <a:cs typeface="+mn-lt"/>
             </a:endParaRPr>
           </a:p>
           <a:p>
-            <a:pPr marL="0" indent="0">
-              <a:buNone/>
-            </a:pPr>
-            <a:r>
-              <a:rPr lang="en-US">
-                <a:ea typeface="+mn-lt"/>
-                <a:cs typeface="+mn-lt"/>
-              </a:rPr>
-              <a:t>     -</a:t>
+            <a:pPr lvl="1"/>
+            <a:r>
+              <a:rPr lang="en-US" dirty="0" err="1">
+                <a:ea typeface="+mn-lt"/>
+                <a:cs typeface="+mn-lt"/>
+              </a:rPr>
+              <a:t>Praćenje</a:t>
             </a:r>
             <a:r>
               <a:rPr lang="en-US" dirty="0">
                 <a:ea typeface="+mn-lt"/>
                 <a:cs typeface="+mn-lt"/>
               </a:rPr>
-              <a:t>Treniranje </a:t>
-            </a:r>
-            <a:r>
-              <a:rPr lang="en-US" err="1">
+              <a:t> </a:t>
+            </a:r>
+            <a:r>
+              <a:rPr lang="en-US" dirty="0" err="1">
+                <a:ea typeface="+mn-lt"/>
+                <a:cs typeface="+mn-lt"/>
+              </a:rPr>
+              <a:t>ponašanja</a:t>
+            </a:r>
+            <a:r>
+              <a:rPr lang="en-US" dirty="0">
+                <a:ea typeface="+mn-lt"/>
+                <a:cs typeface="+mn-lt"/>
+              </a:rPr>
+              <a:t> </a:t>
+            </a:r>
+            <a:r>
+              <a:rPr lang="en-US" dirty="0" err="1">
                 <a:ea typeface="+mn-lt"/>
                 <a:cs typeface="+mn-lt"/>
               </a:rPr>
@@ -14728,25 +14752,53 @@
               <a:t> </a:t>
             </a:r>
             <a:r>
-              <a:rPr lang="en-US" err="1">
-                <a:ea typeface="+mn-lt"/>
-                <a:cs typeface="+mn-lt"/>
-              </a:rPr>
-              <a:t>kroz</a:t>
+              <a:rPr lang="en-US" dirty="0" err="1">
+                <a:ea typeface="+mn-lt"/>
+                <a:cs typeface="+mn-lt"/>
+              </a:rPr>
+              <a:t>na</a:t>
             </a:r>
             <a:r>
               <a:rPr lang="en-US" dirty="0">
                 <a:ea typeface="+mn-lt"/>
                 <a:cs typeface="+mn-lt"/>
               </a:rPr>
+              <a:t> validation </a:t>
+            </a:r>
+            <a:r>
+              <a:rPr lang="en-US" dirty="0" err="1">
+                <a:ea typeface="+mn-lt"/>
+                <a:cs typeface="+mn-lt"/>
+              </a:rPr>
+              <a:t>skupu</a:t>
+            </a:r>
+            <a:endParaRPr lang="sr-Latn-RS" dirty="0">
+              <a:ea typeface="+mn-lt"/>
+              <a:cs typeface="+mn-lt"/>
+            </a:endParaRPr>
+          </a:p>
+          <a:p>
+            <a:pPr lvl="1"/>
+            <a:r>
+              <a:rPr lang="en-US" dirty="0" err="1">
+                <a:ea typeface="+mn-lt"/>
+                <a:cs typeface="+mn-lt"/>
+              </a:rPr>
+              <a:t>Vizuelna</a:t>
+            </a:r>
+            <a:r>
+              <a:rPr lang="en-US" dirty="0">
+                <a:ea typeface="+mn-lt"/>
+                <a:cs typeface="+mn-lt"/>
+              </a:rPr>
               <a:t> </a:t>
             </a:r>
             <a:r>
-              <a:rPr lang="en-US" err="1">
-                <a:ea typeface="+mn-lt"/>
-                <a:cs typeface="+mn-lt"/>
-              </a:rPr>
-              <a:t>više</a:t>
+              <a:rPr lang="en-US" dirty="0" err="1">
+                <a:ea typeface="+mn-lt"/>
+                <a:cs typeface="+mn-lt"/>
+              </a:rPr>
+              <a:t>analiza</a:t>
             </a:r>
             <a:r>
               <a:rPr lang="en-US" dirty="0">
@@ -14756,153 +14808,12 @@
               <a:t> </a:t>
             </a:r>
             <a:r>
-              <a:rPr lang="en-US" err="1">
-                <a:ea typeface="+mn-lt"/>
-                <a:cs typeface="+mn-lt"/>
-              </a:rPr>
-              <a:t>epoha</a:t>
-            </a:r>
-            <a:r>
-              <a:rPr lang="en-US" dirty="0">
-                <a:ea typeface="+mn-lt"/>
-                <a:cs typeface="+mn-lt"/>
-              </a:rPr>
-              <a:t> </a:t>
-            </a:r>
-            <a:endParaRPr lang="en-US" dirty="0"/>
-          </a:p>
-          <a:p>
-            <a:pPr marL="0" indent="0">
-              <a:buNone/>
-            </a:pPr>
-            <a:r>
-              <a:rPr lang="en-US" dirty="0">
-                <a:ea typeface="+mn-lt"/>
-                <a:cs typeface="+mn-lt"/>
-              </a:rPr>
-              <a:t>     -</a:t>
-            </a:r>
-            <a:r>
               <a:rPr lang="en-US" dirty="0" err="1">
                 <a:ea typeface="+mn-lt"/>
                 <a:cs typeface="+mn-lt"/>
               </a:rPr>
-              <a:t>Praćenje</a:t>
-            </a:r>
-            <a:r>
-              <a:rPr lang="en-US" dirty="0">
-                <a:ea typeface="+mn-lt"/>
-                <a:cs typeface="+mn-lt"/>
-              </a:rPr>
-              <a:t> </a:t>
-            </a:r>
-            <a:r>
-              <a:rPr lang="en-US" dirty="0" err="1">
-                <a:ea typeface="+mn-lt"/>
-                <a:cs typeface="+mn-lt"/>
-              </a:rPr>
-              <a:t>ponašanja</a:t>
-            </a:r>
-            <a:r>
-              <a:rPr lang="en-US" dirty="0">
-                <a:ea typeface="+mn-lt"/>
-                <a:cs typeface="+mn-lt"/>
-              </a:rPr>
-              <a:t> </a:t>
-            </a:r>
-            <a:r>
-              <a:rPr lang="en-US" dirty="0" err="1">
-                <a:ea typeface="+mn-lt"/>
-                <a:cs typeface="+mn-lt"/>
-              </a:rPr>
-              <a:t>modela</a:t>
-            </a:r>
-            <a:r>
-              <a:rPr lang="en-US" dirty="0">
-                <a:ea typeface="+mn-lt"/>
-                <a:cs typeface="+mn-lt"/>
-              </a:rPr>
-              <a:t> </a:t>
-            </a:r>
-            <a:r>
-              <a:rPr lang="en-US" dirty="0" err="1">
-                <a:ea typeface="+mn-lt"/>
-                <a:cs typeface="+mn-lt"/>
-              </a:rPr>
-              <a:t>na</a:t>
-            </a:r>
-            <a:r>
-              <a:rPr lang="en-US" dirty="0">
-                <a:ea typeface="+mn-lt"/>
-                <a:cs typeface="+mn-lt"/>
-              </a:rPr>
-              <a:t> validation </a:t>
-            </a:r>
-            <a:r>
-              <a:rPr lang="en-US" dirty="0" err="1">
-                <a:ea typeface="+mn-lt"/>
-                <a:cs typeface="+mn-lt"/>
-              </a:rPr>
-              <a:t>skupu</a:t>
-            </a:r>
-            <a:r>
-              <a:rPr lang="en-US" dirty="0">
-                <a:ea typeface="+mn-lt"/>
-                <a:cs typeface="+mn-lt"/>
-              </a:rPr>
-              <a:t> </a:t>
-            </a:r>
-            <a:endParaRPr lang="en-US" dirty="0"/>
-          </a:p>
-          <a:p>
-            <a:pPr marL="0" indent="0">
-              <a:buNone/>
-            </a:pPr>
-            <a:r>
-              <a:rPr lang="en-US" dirty="0">
-                <a:ea typeface="+mn-lt"/>
-                <a:cs typeface="+mn-lt"/>
-              </a:rPr>
-              <a:t>   -</a:t>
-            </a:r>
-            <a:r>
-              <a:rPr lang="en-US" dirty="0" err="1">
-                <a:ea typeface="+mn-lt"/>
-                <a:cs typeface="+mn-lt"/>
-              </a:rPr>
-              <a:t>Vizuelna</a:t>
-            </a:r>
-            <a:r>
-              <a:rPr lang="en-US" dirty="0">
-                <a:ea typeface="+mn-lt"/>
-                <a:cs typeface="+mn-lt"/>
-              </a:rPr>
-              <a:t> </a:t>
-            </a:r>
-            <a:r>
-              <a:rPr lang="en-US" dirty="0" err="1">
-                <a:ea typeface="+mn-lt"/>
-                <a:cs typeface="+mn-lt"/>
-              </a:rPr>
-              <a:t>analiza</a:t>
-            </a:r>
-            <a:r>
-              <a:rPr lang="en-US" dirty="0">
-                <a:ea typeface="+mn-lt"/>
-                <a:cs typeface="+mn-lt"/>
-              </a:rPr>
-              <a:t> </a:t>
-            </a:r>
-            <a:r>
-              <a:rPr lang="en-US" dirty="0" err="1">
-                <a:ea typeface="+mn-lt"/>
-                <a:cs typeface="+mn-lt"/>
-              </a:rPr>
               <a:t>rezultata</a:t>
             </a:r>
-            <a:endParaRPr lang="en-US" dirty="0" err="1"/>
-          </a:p>
-          <a:p>
             <a:endParaRPr lang="en-US" dirty="0"/>
           </a:p>
         </p:txBody>
@@ -14921,8 +14832,8 @@
         </p:nvSpPr>
         <p:spPr>
           <a:xfrm>
-            <a:off x="7002161" y="2100648"/>
-            <a:ext cx="5581134" cy="1938992"/>
+            <a:off x="6870983" y="2097088"/>
+            <a:ext cx="5581134" cy="1384995"/>
           </a:xfrm>
           <a:prstGeom prst="rect">
             <a:avLst/>
@@ -14958,120 +14869,104 @@
               <a:rPr lang="en-US" sz="2400" dirty="0"/>
               <a:t>:</a:t>
             </a:r>
-            <a:endParaRPr lang="en-US"/>
-          </a:p>
-          <a:p>
-            <a:r>
-              <a:rPr lang="en-US" sz="2400" dirty="0">
-                <a:ea typeface="+mn-lt"/>
-                <a:cs typeface="+mn-lt"/>
-              </a:rPr>
-              <a:t>     - </a:t>
-            </a:r>
-            <a:r>
-              <a:rPr lang="en-US" sz="2400" dirty="0" err="1">
+            <a:endParaRPr lang="sr-Latn-RS" sz="2400" dirty="0"/>
+          </a:p>
+          <a:p>
+            <a:pPr marL="800100" lvl="1" indent="-342900">
+              <a:buFont typeface="Arial"/>
+              <a:buChar char="•"/>
+            </a:pPr>
+            <a:r>
+              <a:rPr lang="en-US" sz="2000" dirty="0" err="1">
                 <a:ea typeface="+mn-lt"/>
                 <a:cs typeface="+mn-lt"/>
               </a:rPr>
               <a:t>Iscrtavanje</a:t>
             </a:r>
             <a:r>
-              <a:rPr lang="en-US" sz="2400" dirty="0">
+              <a:rPr lang="en-US" sz="2000" dirty="0">
                 <a:ea typeface="+mn-lt"/>
                 <a:cs typeface="+mn-lt"/>
               </a:rPr>
               <a:t> steering angle </a:t>
             </a:r>
             <a:r>
-              <a:rPr lang="en-US" sz="2400" dirty="0" err="1">
+              <a:rPr lang="en-US" sz="2000" dirty="0" err="1">
                 <a:ea typeface="+mn-lt"/>
                 <a:cs typeface="+mn-lt"/>
               </a:rPr>
               <a:t>linije</a:t>
             </a:r>
-            <a:r>
-              <a:rPr lang="en-US" sz="2400" dirty="0">
-                <a:ea typeface="+mn-lt"/>
-                <a:cs typeface="+mn-lt"/>
-              </a:rPr>
-              <a:t> </a:t>
-            </a:r>
-            <a:endParaRPr lang="en-US" dirty="0">
+            <a:endParaRPr lang="sr-Latn-RS" sz="2000" dirty="0">
               <a:ea typeface="+mn-lt"/>
               <a:cs typeface="+mn-lt"/>
             </a:endParaRPr>
           </a:p>
           <a:p>
-            <a:r>
-              <a:rPr lang="en-US" sz="2400" dirty="0">
-                <a:ea typeface="+mn-lt"/>
-                <a:cs typeface="+mn-lt"/>
-              </a:rPr>
-              <a:t>     - </a:t>
-            </a:r>
-            <a:r>
-              <a:rPr lang="en-US" sz="2400" dirty="0" err="1">
+            <a:pPr marL="800100" lvl="1" indent="-342900">
+              <a:buFont typeface="Arial"/>
+              <a:buChar char="•"/>
+            </a:pPr>
+            <a:r>
+              <a:rPr lang="en-US" sz="2000" dirty="0" err="1">
                 <a:ea typeface="+mn-lt"/>
                 <a:cs typeface="+mn-lt"/>
               </a:rPr>
               <a:t>Generisanje</a:t>
             </a:r>
             <a:r>
-              <a:rPr lang="en-US" sz="2400" dirty="0">
+              <a:rPr lang="en-US" sz="2000" dirty="0">
                 <a:ea typeface="+mn-lt"/>
                 <a:cs typeface="+mn-lt"/>
               </a:rPr>
               <a:t> </a:t>
             </a:r>
             <a:r>
-              <a:rPr lang="en-US" sz="2400" dirty="0" err="1">
+              <a:rPr lang="en-US" sz="2000" dirty="0" err="1">
                 <a:ea typeface="+mn-lt"/>
                 <a:cs typeface="+mn-lt"/>
               </a:rPr>
               <a:t>izlaznog</a:t>
             </a:r>
             <a:r>
-              <a:rPr lang="en-US" sz="2400" dirty="0">
+              <a:rPr lang="en-US" sz="2000" dirty="0">
                 <a:ea typeface="+mn-lt"/>
                 <a:cs typeface="+mn-lt"/>
               </a:rPr>
               <a:t> </a:t>
             </a:r>
             <a:r>
-              <a:rPr lang="en-US" sz="2400" dirty="0" err="1">
+              <a:rPr lang="en-US" sz="2000" dirty="0" err="1">
                 <a:ea typeface="+mn-lt"/>
                 <a:cs typeface="+mn-lt"/>
               </a:rPr>
               <a:t>videa</a:t>
             </a:r>
-            <a:r>
-              <a:rPr lang="en-US" sz="2400" dirty="0">
-                <a:ea typeface="+mn-lt"/>
-                <a:cs typeface="+mn-lt"/>
-              </a:rPr>
-              <a:t> </a:t>
-            </a:r>
-            <a:endParaRPr lang="en-US"/>
-          </a:p>
-          <a:p>
-            <a:r>
-              <a:rPr lang="en-US" sz="2400" dirty="0">
-                <a:ea typeface="+mn-lt"/>
-                <a:cs typeface="+mn-lt"/>
-              </a:rPr>
-              <a:t>     - Provera lane change </a:t>
-            </a:r>
-            <a:r>
-              <a:rPr lang="en-US" sz="2400" dirty="0" err="1">
+            <a:endParaRPr lang="sr-Latn-RS" sz="2000" dirty="0">
+              <a:ea typeface="+mn-lt"/>
+              <a:cs typeface="+mn-lt"/>
+            </a:endParaRPr>
+          </a:p>
+          <a:p>
+            <a:pPr marL="800100" lvl="1" indent="-342900">
+              <a:buFont typeface="Arial"/>
+              <a:buChar char="•"/>
+            </a:pPr>
+            <a:r>
+              <a:rPr lang="en-US" sz="2000" dirty="0">
+                <a:ea typeface="+mn-lt"/>
+                <a:cs typeface="+mn-lt"/>
+              </a:rPr>
+              <a:t>Provera lane change </a:t>
+            </a:r>
+            <a:r>
+              <a:rPr lang="en-US" sz="2000" dirty="0" err="1">
                 <a:ea typeface="+mn-lt"/>
                 <a:cs typeface="+mn-lt"/>
               </a:rPr>
               <a:t>upozorenja</a:t>
             </a:r>
-            <a:endParaRPr lang="en-US" dirty="0" err="1"/>
-          </a:p>
-          <a:p>
-            <a:endParaRPr lang="en-US" sz="2400" dirty="0"/>
+            <a:endParaRPr lang="en-US" sz="2000" dirty="0"/>
           </a:p>
         </p:txBody>
       </p:sp>
@@ -15858,9 +15753,9 @@
               <a:rPr lang="sr-Latn-RS" dirty="0">
                 <a:hlinkClick r:id="rId2"/>
               </a:rPr>
-              <a:t>https://drive.google.com/file/d/1y9eggug7QbPKou0hVWbTBR0KSBy1uIpD/view?usp=sharing</a:t>
-            </a:r>
-            <a:endParaRPr lang="sr-Latn-RS" dirty="0"/>
+              <a:t>https://drive.google.com/file/d/1XGjAtChqIL5fgNQVVZiw0ZP5Cm_L7aOV/view?usp=sharing</a:t>
+            </a:r>
+            <a:endParaRPr lang="en-US" dirty="0"/>
           </a:p>
           <a:p>
             <a:r>
@@ -15916,7 +15811,7 @@
         <p:spPr>
           <a:xfrm>
             <a:off x="1875164" y="4318168"/>
-            <a:ext cx="2755885" cy="369332"/>
+            <a:ext cx="2984703" cy="923330"/>
           </a:xfrm>
           <a:prstGeom prst="rect">
             <a:avLst/>
@@ -15929,9 +15824,82 @@
           </a:bodyPr>
           <a:lstStyle/>
           <a:p>
+            <a:pPr algn="ctr"/>
             <a:r>
               <a:rPr lang="sr-Latn-RS" dirty="0"/>
-              <a:t>Broj trening i test podataka</a:t>
+              <a:t>Broj trening</a:t>
+            </a:r>
+            <a:r>
+              <a:rPr lang="en-US" dirty="0"/>
+              <a:t> </a:t>
+            </a:r>
+            <a:r>
+              <a:rPr lang="en-US" dirty="0" err="1"/>
+              <a:t>primeraka</a:t>
+            </a:r>
+            <a:r>
+              <a:rPr lang="en-US" dirty="0"/>
+              <a:t> (plus koji se </a:t>
+            </a:r>
+            <a:r>
+              <a:rPr lang="en-US" dirty="0" err="1"/>
+              <a:t>dodaju</a:t>
+            </a:r>
+            <a:r>
+              <a:rPr lang="en-US" dirty="0"/>
+              <a:t> </a:t>
+            </a:r>
+            <a:r>
+              <a:rPr lang="en-US" dirty="0" err="1"/>
+              <a:t>augmentacijom</a:t>
+            </a:r>
+            <a:r>
+              <a:rPr lang="en-US" dirty="0"/>
+              <a:t>)</a:t>
+            </a:r>
+            <a:r>
+              <a:rPr lang="sr-Latn-RS" dirty="0"/>
+              <a:t> i test </a:t>
+            </a:r>
+            <a:r>
+              <a:rPr lang="en-US" dirty="0" err="1"/>
+              <a:t>primeraka</a:t>
+            </a:r>
+            <a:endParaRPr lang="en-US" dirty="0"/>
+          </a:p>
+        </p:txBody>
+      </p:sp>
+      <p:sp>
+        <p:nvSpPr>
+          <p:cNvPr id="9" name="TextBox 8">
+            <a:extLst>
+              <a:ext uri="{FF2B5EF4-FFF2-40B4-BE49-F238E27FC236}">
+                <a16:creationId xmlns:a16="http://schemas.microsoft.com/office/drawing/2014/main" id="{918FDE6D-9BC8-DD50-D5CD-1D63F522B0D3}"/>
+              </a:ext>
+            </a:extLst>
+          </p:cNvPr>
+          <p:cNvSpPr txBox="1"/>
+          <p:nvPr/>
+        </p:nvSpPr>
+        <p:spPr>
+          <a:xfrm>
+            <a:off x="7115212" y="5446056"/>
+            <a:ext cx="2256515" cy="369332"/>
+          </a:xfrm>
+          <a:prstGeom prst="rect">
+            <a:avLst/>
+          </a:prstGeom>
+          <a:noFill/>
+        </p:spPr>
+        <p:txBody>
+          <a:bodyPr wrap="none" rtlCol="0">
+            <a:spAutoFit/>
+          </a:bodyPr>
+          <a:lstStyle/>
+          <a:p>
+            <a:r>
+              <a:rPr lang="sr-Latn-RS" dirty="0"/>
+              <a:t>Slike, uglovi, sekvence</a:t>
             </a:r>
             <a:endParaRPr lang="en-US" dirty="0"/>
           </a:p>
@@ -15939,10 +15907,10 @@
       </p:sp>
       <p:pic>
         <p:nvPicPr>
-          <p:cNvPr id="8" name="Picture 7">
+          <p:cNvPr id="7" name="Picture 6">
             <a:extLst>
               <a:ext uri="{FF2B5EF4-FFF2-40B4-BE49-F238E27FC236}">
-                <a16:creationId xmlns:a16="http://schemas.microsoft.com/office/drawing/2014/main" id="{B0CFA1DA-B204-B611-A9C3-3928F340046E}"/>
+                <a16:creationId xmlns:a16="http://schemas.microsoft.com/office/drawing/2014/main" id="{63DDF53A-7B24-B727-0F95-9C84CDFF5CA4}"/>
               </a:ext>
             </a:extLst>
           </p:cNvPr>
@@ -15959,50 +15927,14 @@
         </p:blipFill>
         <p:spPr>
           <a:xfrm>
-            <a:off x="6300728" y="3290645"/>
-            <a:ext cx="3365664" cy="1862023"/>
+            <a:off x="6457283" y="3130538"/>
+            <a:ext cx="3572374" cy="2238687"/>
           </a:xfrm>
           <a:prstGeom prst="rect">
             <a:avLst/>
           </a:prstGeom>
         </p:spPr>
       </p:pic>
-      <p:sp>
-        <p:nvSpPr>
-          <p:cNvPr id="9" name="TextBox 8">
-            <a:extLst>
-              <a:ext uri="{FF2B5EF4-FFF2-40B4-BE49-F238E27FC236}">
-                <a16:creationId xmlns:a16="http://schemas.microsoft.com/office/drawing/2014/main" id="{918FDE6D-9BC8-DD50-D5CD-1D63F522B0D3}"/>
-              </a:ext>
-            </a:extLst>
-          </p:cNvPr>
-          <p:cNvSpPr txBox="1"/>
-          <p:nvPr/>
-        </p:nvSpPr>
-        <p:spPr>
-          <a:xfrm>
-            <a:off x="6855303" y="5184559"/>
-            <a:ext cx="2256515" cy="369332"/>
-          </a:xfrm>
-          <a:prstGeom prst="rect">
-            <a:avLst/>
-          </a:prstGeom>
-          <a:noFill/>
-        </p:spPr>
-        <p:txBody>
-          <a:bodyPr wrap="none" rtlCol="0">
-            <a:spAutoFit/>
-          </a:bodyPr>
-          <a:lstStyle/>
-          <a:p>
-            <a:r>
-              <a:rPr lang="sr-Latn-RS" dirty="0"/>
-              <a:t>Slike, uglovi, sekvence</a:t>
-            </a:r>
-            <a:endParaRPr lang="en-US" dirty="0"/>
-          </a:p>
-        </p:txBody>
-      </p:sp>
     </p:spTree>
     <p:extLst>
       <p:ext uri="{BB962C8B-B14F-4D97-AF65-F5344CB8AC3E}">
@@ -16092,90 +16024,14 @@
         </p:blipFill>
         <p:spPr>
           <a:xfrm>
-            <a:off x="435006" y="710214"/>
-            <a:ext cx="4332302" cy="5048991"/>
+            <a:off x="3589348" y="729959"/>
+            <a:ext cx="4631841" cy="5398082"/>
           </a:xfrm>
           <a:prstGeom prst="rect">
             <a:avLst/>
           </a:prstGeom>
         </p:spPr>
       </p:pic>
-      <p:pic>
-        <p:nvPicPr>
-          <p:cNvPr id="7" name="Picture 6">
-            <a:extLst>
-              <a:ext uri="{FF2B5EF4-FFF2-40B4-BE49-F238E27FC236}">
-                <a16:creationId xmlns:a16="http://schemas.microsoft.com/office/drawing/2014/main" id="{5C2EF234-CBA3-A919-D33A-CCC109026E09}"/>
-              </a:ext>
-            </a:extLst>
-          </p:cNvPr>
-          <p:cNvPicPr>
-            <a:picLocks noChangeAspect="1"/>
-          </p:cNvPicPr>
-          <p:nvPr/>
-        </p:nvPicPr>
-        <p:blipFill>
-          <a:blip r:embed="rId3"/>
-          <a:stretch>
-            <a:fillRect/>
-          </a:stretch>
-        </p:blipFill>
-        <p:spPr>
-          <a:xfrm>
-            <a:off x="5007006" y="710214"/>
-            <a:ext cx="6971930" cy="5048991"/>
-          </a:xfrm>
-          <a:prstGeom prst="rect">
-            <a:avLst/>
-          </a:prstGeom>
-        </p:spPr>
-      </p:pic>
-      <p:sp>
-        <p:nvSpPr>
-          <p:cNvPr id="8" name="TextBox 7">
-            <a:extLst>
-              <a:ext uri="{FF2B5EF4-FFF2-40B4-BE49-F238E27FC236}">
-                <a16:creationId xmlns:a16="http://schemas.microsoft.com/office/drawing/2014/main" id="{B07FA6B9-E182-FEB8-C658-21178308423C}"/>
-              </a:ext>
-            </a:extLst>
-          </p:cNvPr>
-          <p:cNvSpPr txBox="1"/>
-          <p:nvPr/>
-        </p:nvSpPr>
-        <p:spPr>
-          <a:xfrm>
-            <a:off x="2050742" y="6295136"/>
-            <a:ext cx="7342266" cy="646331"/>
-          </a:xfrm>
-          <a:prstGeom prst="rect">
-            <a:avLst/>
-          </a:prstGeom>
-          <a:noFill/>
-        </p:spPr>
-        <p:txBody>
-          <a:bodyPr wrap="none" rtlCol="0">
-            <a:spAutoFit/>
-          </a:bodyPr>
-          <a:lstStyle/>
-          <a:p>
-            <a:pPr marL="285750" indent="-285750">
-              <a:buFont typeface="Arial" panose="020B0604020202020204" pitchFamily="34" charset="0"/>
-              <a:buChar char="•"/>
-            </a:pPr>
-            <a:r>
-              <a:rPr lang="sr-Latn-RS" dirty="0"/>
-              <a:t>Malo lošiji rezultati jer je većina trenging podataka imala steering angle 0</a:t>
-            </a:r>
-          </a:p>
-          <a:p>
-            <a:pPr marL="285750" indent="-285750">
-              <a:buFont typeface="Arial" panose="020B0604020202020204" pitchFamily="34" charset="0"/>
-              <a:buChar char="•"/>
-            </a:pPr>
-            <a:endParaRPr lang="en-US" dirty="0"/>
-          </a:p>
-        </p:txBody>
-      </p:sp>
       <p:sp>
         <p:nvSpPr>
           <p:cNvPr id="9" name="TextBox 8">
@@ -16190,7 +16046,7 @@
         </p:nvSpPr>
         <p:spPr>
           <a:xfrm>
-            <a:off x="1276339" y="5759205"/>
+            <a:off x="4771182" y="6147786"/>
             <a:ext cx="2649636" cy="369332"/>
           </a:xfrm>
           <a:prstGeom prst="rect">
@@ -16207,42 +16063,6 @@
             <a:r>
               <a:rPr lang="sr-Latn-RS" dirty="0"/>
               <a:t>CNN + LSTM model output</a:t>
-            </a:r>
-            <a:endParaRPr lang="en-US" dirty="0"/>
-          </a:p>
-        </p:txBody>
-      </p:sp>
-      <p:sp>
-        <p:nvSpPr>
-          <p:cNvPr id="10" name="TextBox 9">
-            <a:extLst>
-              <a:ext uri="{FF2B5EF4-FFF2-40B4-BE49-F238E27FC236}">
-                <a16:creationId xmlns:a16="http://schemas.microsoft.com/office/drawing/2014/main" id="{8D0565CE-900B-9FB0-6D6D-6E235E470079}"/>
-              </a:ext>
-            </a:extLst>
-          </p:cNvPr>
-          <p:cNvSpPr txBox="1"/>
-          <p:nvPr/>
-        </p:nvSpPr>
-        <p:spPr>
-          <a:xfrm>
-            <a:off x="5903191" y="5741138"/>
-            <a:ext cx="5179559" cy="369332"/>
-          </a:xfrm>
-          <a:prstGeom prst="rect">
-            <a:avLst/>
-          </a:prstGeom>
-          <a:noFill/>
-        </p:spPr>
-        <p:txBody>
-          <a:bodyPr wrap="none" rtlCol="0">
-            <a:spAutoFit/>
-          </a:bodyPr>
-          <a:lstStyle/>
-          <a:p>
-            <a:r>
-              <a:rPr lang="sr-Latn-RS" dirty="0"/>
-              <a:t>Output epoha i prosečne kvadratne i apsolutne greške</a:t>
             </a:r>
             <a:endParaRPr lang="en-US" dirty="0"/>
           </a:p>
@@ -16278,21 +16098,54 @@
           <a:chExt cx="0" cy="0"/>
         </a:xfrm>
       </p:grpSpPr>
+      <p:sp>
+        <p:nvSpPr>
+          <p:cNvPr id="2" name="Title 1">
+            <a:extLst>
+              <a:ext uri="{FF2B5EF4-FFF2-40B4-BE49-F238E27FC236}">
+                <a16:creationId xmlns:a16="http://schemas.microsoft.com/office/drawing/2014/main" id="{1F2A6B73-AA2D-008C-44CA-19D8A4B5ECF9}"/>
+              </a:ext>
+            </a:extLst>
+          </p:cNvPr>
+          <p:cNvSpPr>
+            <a:spLocks noGrp="1"/>
+          </p:cNvSpPr>
+          <p:nvPr>
+            <p:ph type="title"/>
+          </p:nvPr>
+        </p:nvSpPr>
+        <p:spPr>
+          <a:xfrm>
+            <a:off x="1141412" y="-276304"/>
+            <a:ext cx="9905998" cy="1478570"/>
+          </a:xfrm>
+        </p:spPr>
+        <p:txBody>
+          <a:bodyPr/>
+          <a:lstStyle/>
+          <a:p>
+            <a:pPr algn="ctr"/>
+            <a:r>
+              <a:rPr lang="sr-Latn-RS" dirty="0"/>
+              <a:t>Output modela i epoha</a:t>
+            </a:r>
+            <a:endParaRPr lang="en-US" dirty="0"/>
+          </a:p>
+        </p:txBody>
+      </p:sp>
       <p:pic>
         <p:nvPicPr>
-          <p:cNvPr id="4" name="Content Placeholder 3">
+          <p:cNvPr id="5" name="Picture 4">
             <a:extLst>
               <a:ext uri="{FF2B5EF4-FFF2-40B4-BE49-F238E27FC236}">
-                <a16:creationId xmlns:a16="http://schemas.microsoft.com/office/drawing/2014/main" id="{494AAD19-20E7-D578-B344-EDBB263CCB81}"/>
+                <a16:creationId xmlns:a16="http://schemas.microsoft.com/office/drawing/2014/main" id="{9EFB5E81-D8BC-098B-F34B-CDF33882B062}"/>
               </a:ext>
             </a:extLst>
           </p:cNvPr>
           <p:cNvPicPr>
-            <a:picLocks noGrp="1" noChangeAspect="1"/>
+            <a:picLocks noChangeAspect="1"/>
           </p:cNvPicPr>
-          <p:nvPr>
-            <p:ph idx="1"/>
-          </p:nvPr>
+          <p:nvPr/>
         </p:nvPicPr>
         <p:blipFill>
           <a:blip r:embed="rId2"/>
@@ -16302,8 +16155,8 @@
         </p:blipFill>
         <p:spPr>
           <a:xfrm>
-            <a:off x="700" y="2073065"/>
-            <a:ext cx="12191999" cy="4178308"/>
+            <a:off x="1421746" y="780680"/>
+            <a:ext cx="9345329" cy="5179853"/>
           </a:xfrm>
           <a:prstGeom prst="rect">
             <a:avLst/>
@@ -16312,10 +16165,10 @@
       </p:pic>
       <p:sp>
         <p:nvSpPr>
-          <p:cNvPr id="5" name="TextBox 4">
+          <p:cNvPr id="10" name="TextBox 9">
             <a:extLst>
               <a:ext uri="{FF2B5EF4-FFF2-40B4-BE49-F238E27FC236}">
-                <a16:creationId xmlns:a16="http://schemas.microsoft.com/office/drawing/2014/main" id="{14F6337E-B52F-A7D0-0BCF-EFD4F1D4E43A}"/>
+                <a16:creationId xmlns:a16="http://schemas.microsoft.com/office/drawing/2014/main" id="{8D0565CE-900B-9FB0-6D6D-6E235E470079}"/>
               </a:ext>
             </a:extLst>
           </p:cNvPr>
@@ -16324,8 +16177,8 @@
         </p:nvSpPr>
         <p:spPr>
           <a:xfrm>
-            <a:off x="288323" y="1009135"/>
-            <a:ext cx="9947189" cy="461665"/>
+            <a:off x="3504630" y="5943599"/>
+            <a:ext cx="5179559" cy="369332"/>
           </a:xfrm>
           <a:prstGeom prst="rect">
             <a:avLst/>
@@ -16333,41 +16186,23 @@
           <a:noFill/>
         </p:spPr>
         <p:txBody>
-          <a:bodyPr rot="0" spcFirstLastPara="0" vertOverflow="overflow" horzOverflow="overflow" vert="horz" wrap="square" lIns="91440" tIns="45720" rIns="91440" bIns="45720" numCol="1" spcCol="0" rtlCol="0" fromWordArt="0" anchor="t" anchorCtr="0" forceAA="0" compatLnSpc="1">
-            <a:prstTxWarp prst="textNoShape">
-              <a:avLst/>
-            </a:prstTxWarp>
+          <a:bodyPr wrap="none" rtlCol="0">
             <a:spAutoFit/>
           </a:bodyPr>
           <a:lstStyle/>
           <a:p>
             <a:r>
-              <a:rPr lang="en-US" sz="2400" dirty="0"/>
-              <a:t>MSE I MAE </a:t>
-            </a:r>
-            <a:r>
-              <a:rPr lang="en-US" sz="2400" dirty="0" err="1"/>
-              <a:t>kroz</a:t>
-            </a:r>
-            <a:r>
-              <a:rPr lang="en-US" sz="2400" dirty="0"/>
-              <a:t> </a:t>
-            </a:r>
-            <a:r>
-              <a:rPr lang="en-US" sz="2400" dirty="0" err="1"/>
-              <a:t>epohe</a:t>
-            </a:r>
-            <a:r>
-              <a:rPr lang="en-US" sz="2400" dirty="0"/>
-              <a:t>:</a:t>
-            </a:r>
+              <a:rPr lang="sr-Latn-RS" dirty="0"/>
+              <a:t>Output epoha i prosečne kvadratne i apsolutne greške</a:t>
+            </a:r>
+            <a:endParaRPr lang="en-US" dirty="0"/>
           </a:p>
         </p:txBody>
       </p:sp>
     </p:spTree>
     <p:extLst>
       <p:ext uri="{BB962C8B-B14F-4D97-AF65-F5344CB8AC3E}">
-        <p14:creationId xmlns:p14="http://schemas.microsoft.com/office/powerpoint/2010/main" val="4125797833"/>
+        <p14:creationId xmlns:p14="http://schemas.microsoft.com/office/powerpoint/2010/main" val="1320222002"/>
       </p:ext>
     </p:extLst>
   </p:cSld>
@@ -16426,99 +16261,99 @@
               <a:buNone/>
             </a:pPr>
             <a:r>
-              <a:rPr lang="en-US"/>
+              <a:rPr lang="en-US" dirty="0"/>
               <a:t>Pored </a:t>
             </a:r>
             <a:r>
-              <a:rPr lang="en-US" err="1"/>
+              <a:rPr lang="en-US" dirty="0" err="1"/>
               <a:t>redovnih</a:t>
             </a:r>
             <a:r>
-              <a:rPr lang="en-US"/>
+              <a:rPr lang="en-US" dirty="0"/>
               <a:t> </a:t>
             </a:r>
             <a:r>
-              <a:rPr lang="en-US" err="1"/>
+              <a:rPr lang="en-US" dirty="0" err="1"/>
               <a:t>instalacija</a:t>
             </a:r>
             <a:r>
-              <a:rPr lang="en-US"/>
+              <a:rPr lang="en-US" dirty="0"/>
               <a:t> </a:t>
             </a:r>
             <a:r>
-              <a:rPr lang="en-US" err="1"/>
+              <a:rPr lang="en-US" dirty="0" err="1"/>
               <a:t>programa</a:t>
             </a:r>
             <a:r>
-              <a:rPr lang="en-US"/>
+              <a:rPr lang="en-US" dirty="0"/>
               <a:t> za </a:t>
             </a:r>
             <a:r>
-              <a:rPr lang="en-US" err="1"/>
+              <a:rPr lang="en-US" dirty="0" err="1"/>
               <a:t>ve</a:t>
             </a:r>
             <a:r>
-              <a:rPr lang="sr-Latn-RS"/>
+              <a:rPr lang="sr-Latn-RS" dirty="0"/>
               <a:t>ž</a:t>
             </a:r>
             <a:r>
-              <a:rPr lang="en-US"/>
+              <a:rPr lang="en-US" dirty="0"/>
               <a:t>be </a:t>
             </a:r>
             <a:r>
-              <a:rPr lang="en-US" err="1"/>
+              <a:rPr lang="en-US" dirty="0" err="1"/>
               <a:t>neophodno</a:t>
             </a:r>
             <a:r>
-              <a:rPr lang="en-US"/>
+              <a:rPr lang="en-US" dirty="0"/>
               <a:t> je </a:t>
             </a:r>
             <a:r>
-              <a:rPr lang="en-US" err="1"/>
+              <a:rPr lang="en-US" dirty="0" err="1"/>
               <a:t>instalirati</a:t>
             </a:r>
             <a:r>
-              <a:rPr lang="en-US"/>
+              <a:rPr lang="en-US" dirty="0"/>
               <a:t> </a:t>
             </a:r>
             <a:r>
-              <a:rPr lang="en-US" err="1"/>
+              <a:rPr lang="en-US" dirty="0" err="1"/>
               <a:t>navedeno</a:t>
             </a:r>
             <a:r>
-              <a:rPr lang="en-US"/>
+              <a:rPr lang="en-US" dirty="0"/>
               <a:t> </a:t>
             </a:r>
             <a:r>
-              <a:rPr lang="en-US" err="1"/>
+              <a:rPr lang="en-US" dirty="0" err="1"/>
               <a:t>ispod</a:t>
             </a:r>
             <a:r>
-              <a:rPr lang="en-US"/>
+              <a:rPr lang="en-US" dirty="0"/>
               <a:t> </a:t>
             </a:r>
             <a:r>
-              <a:rPr lang="en-US" err="1"/>
+              <a:rPr lang="en-US" dirty="0" err="1"/>
               <a:t>kako</a:t>
             </a:r>
             <a:r>
-              <a:rPr lang="en-US"/>
+              <a:rPr lang="en-US" dirty="0"/>
               <a:t> bi se </a:t>
             </a:r>
             <a:r>
-              <a:rPr lang="en-US" err="1"/>
+              <a:rPr lang="en-US" dirty="0" err="1"/>
               <a:t>pokrenuo</a:t>
             </a:r>
             <a:r>
-              <a:rPr lang="en-US"/>
+              <a:rPr lang="en-US" dirty="0"/>
               <a:t> </a:t>
             </a:r>
             <a:r>
-              <a:rPr lang="en-US" err="1"/>
+              <a:rPr lang="en-US" dirty="0" err="1"/>
               <a:t>projekat</a:t>
             </a:r>
             <a:r>
-              <a:rPr lang="en-US"/>
+              <a:rPr lang="en-US" dirty="0"/>
               <a:t>:</a:t>
             </a:r>
           </a:p>
@@ -16527,156 +16362,147 @@
               <a:buNone/>
             </a:pPr>
             <a:r>
-              <a:rPr lang="en-US"/>
+              <a:rPr lang="en-US" dirty="0"/>
               <a:t>    &gt;&gt; pip install </a:t>
             </a:r>
             <a:r>
-              <a:rPr lang="en-US" err="1"/>
+              <a:rPr lang="en-US" dirty="0" err="1"/>
               <a:t>imageio</a:t>
             </a:r>
             <a:r>
-              <a:rPr lang="en-US"/>
+              <a:rPr lang="en-US" dirty="0"/>
               <a:t>[</a:t>
             </a:r>
             <a:r>
-              <a:rPr lang="en-US" err="1"/>
+              <a:rPr lang="en-US" dirty="0" err="1"/>
               <a:t>ffmpeg</a:t>
             </a:r>
             <a:r>
-              <a:rPr lang="en-US"/>
+              <a:rPr lang="en-US" dirty="0"/>
               <a:t>]</a:t>
             </a:r>
-            <a:endParaRPr lang="sr-Latn-RS"/>
+            <a:endParaRPr lang="sr-Latn-RS" dirty="0"/>
           </a:p>
           <a:p>
             <a:pPr marL="0" indent="0">
               <a:buNone/>
             </a:pPr>
             <a:r>
-              <a:rPr lang="en-US" err="1"/>
+              <a:rPr lang="en-US" dirty="0" err="1"/>
               <a:t>Projekat</a:t>
             </a:r>
             <a:r>
-              <a:rPr lang="en-US"/>
+              <a:rPr lang="en-US" dirty="0"/>
               <a:t> je </a:t>
             </a:r>
             <a:r>
-              <a:rPr lang="en-US" err="1"/>
+              <a:rPr lang="en-US" dirty="0" err="1"/>
               <a:t>dostupan</a:t>
             </a:r>
             <a:r>
-              <a:rPr lang="en-US"/>
+              <a:rPr lang="en-US" dirty="0"/>
               <a:t> </a:t>
             </a:r>
             <a:r>
-              <a:rPr lang="en-US" err="1"/>
+              <a:rPr lang="en-US" dirty="0" err="1"/>
               <a:t>na</a:t>
             </a:r>
             <a:r>
-              <a:rPr lang="en-US"/>
+              <a:rPr lang="en-US" dirty="0"/>
               <a:t> https://github.com/jglintic/duboko_ucenje</a:t>
             </a:r>
           </a:p>
           <a:p>
+            <a:r>
+              <a:rPr lang="en-US" dirty="0" err="1"/>
+              <a:t>Pokretan</a:t>
+            </a:r>
+            <a:r>
+              <a:rPr lang="en-US" dirty="0"/>
+              <a:t> je </a:t>
+            </a:r>
+            <a:r>
+              <a:rPr lang="en-US" dirty="0" err="1"/>
+              <a:t>na</a:t>
+            </a:r>
+            <a:r>
+              <a:rPr lang="en-US" dirty="0"/>
+              <a:t> Windows OS-u</a:t>
+            </a:r>
+            <a:endParaRPr lang="sr-Latn-RS" dirty="0"/>
+          </a:p>
+          <a:p>
+            <a:r>
+              <a:rPr lang="en-US" dirty="0" err="1"/>
+              <a:t>Pokre</a:t>
+            </a:r>
+            <a:r>
+              <a:rPr lang="sr-Latn-RS" dirty="0"/>
+              <a:t>ć</a:t>
+            </a:r>
+            <a:r>
+              <a:rPr lang="en-US" dirty="0"/>
+              <a:t>e se </a:t>
+            </a:r>
+            <a:r>
+              <a:rPr lang="en-US" dirty="0" err="1"/>
+              <a:t>sa</a:t>
+            </a:r>
+            <a:r>
+              <a:rPr lang="en-US" dirty="0"/>
+              <a:t> </a:t>
+            </a:r>
+            <a:r>
+              <a:rPr lang="en-US" dirty="0" err="1"/>
+              <a:t>putanje</a:t>
+            </a:r>
+            <a:r>
+              <a:rPr lang="en-US" dirty="0"/>
+              <a:t> </a:t>
+            </a:r>
+            <a:r>
+              <a:rPr lang="en-US" dirty="0" err="1"/>
+              <a:t>gde</a:t>
+            </a:r>
+            <a:r>
+              <a:rPr lang="en-US" dirty="0"/>
+              <a:t> se </a:t>
+            </a:r>
+            <a:r>
+              <a:rPr lang="en-US" dirty="0" err="1"/>
+              <a:t>nalazi</a:t>
+            </a:r>
+            <a:endParaRPr lang="sr-Latn-RS" dirty="0"/>
+          </a:p>
+          <a:p>
             <a:pPr marL="0" indent="0">
               <a:buNone/>
             </a:pPr>
             <a:r>
-              <a:rPr lang="en-US"/>
-              <a:t>- </a:t>
-            </a:r>
-            <a:r>
-              <a:rPr lang="en-US" err="1"/>
-              <a:t>Pokretan</a:t>
-            </a:r>
-            <a:r>
-              <a:rPr lang="en-US"/>
-              <a:t> je </a:t>
-            </a:r>
-            <a:r>
-              <a:rPr lang="en-US" err="1"/>
-              <a:t>na</a:t>
-            </a:r>
-            <a:r>
-              <a:rPr lang="en-US"/>
-              <a:t> Windows OS-u</a:t>
-            </a:r>
-          </a:p>
-          <a:p>
-            <a:pPr>
-              <a:buFontTx/>
-              <a:buChar char="-"/>
+              <a:rPr lang="en-US" dirty="0"/>
+              <a:t> project.py </a:t>
+            </a:r>
+            <a:r>
+              <a:rPr lang="en-US" dirty="0" err="1"/>
+              <a:t>komandom</a:t>
+            </a:r>
+            <a:r>
+              <a:rPr lang="sr-Latn-RS" dirty="0"/>
+              <a:t>:</a:t>
+            </a:r>
+            <a:endParaRPr lang="en-US" dirty="0"/>
+          </a:p>
+          <a:p>
+            <a:pPr marL="0" indent="0">
+              <a:buNone/>
             </a:pPr>
             <a:r>
-              <a:rPr lang="en-US" err="1"/>
-              <a:t>Pokre</a:t>
-            </a:r>
-            <a:r>
-              <a:rPr lang="sr-Latn-RS"/>
-              <a:t>ć</a:t>
-            </a:r>
-            <a:r>
-              <a:rPr lang="en-US"/>
-              <a:t>e se </a:t>
-            </a:r>
-            <a:r>
-              <a:rPr lang="en-US" err="1"/>
-              <a:t>sa</a:t>
-            </a:r>
-            <a:r>
-              <a:rPr lang="en-US"/>
-              <a:t> </a:t>
-            </a:r>
-            <a:r>
-              <a:rPr lang="en-US" err="1"/>
-              <a:t>putanje</a:t>
-            </a:r>
-            <a:r>
-              <a:rPr lang="en-US"/>
-              <a:t> </a:t>
-            </a:r>
-            <a:r>
-              <a:rPr lang="en-US" err="1"/>
-              <a:t>gde</a:t>
-            </a:r>
-            <a:r>
-              <a:rPr lang="en-US"/>
-              <a:t> se </a:t>
-            </a:r>
-            <a:r>
-              <a:rPr lang="en-US" err="1"/>
-              <a:t>nalazi</a:t>
-            </a:r>
-            <a:endParaRPr lang="sr-Latn-RS"/>
-          </a:p>
-          <a:p>
-            <a:pPr marL="0" indent="0">
-              <a:buNone/>
-            </a:pPr>
-            <a:r>
-              <a:rPr lang="en-US"/>
-              <a:t> project.py </a:t>
-            </a:r>
-            <a:r>
-              <a:rPr lang="en-US" err="1"/>
-              <a:t>komandom</a:t>
-            </a:r>
-            <a:r>
-              <a:rPr lang="en-US"/>
-              <a:t>:</a:t>
-            </a:r>
-          </a:p>
-          <a:p>
-            <a:pPr marL="0" indent="0">
-              <a:buNone/>
-            </a:pPr>
-            <a:r>
-              <a:rPr lang="sr-Latn-RS"/>
-              <a:t>  </a:t>
-            </a:r>
-            <a:r>
-              <a:rPr lang="en-US"/>
-              <a:t>  &gt;&gt; python project.py</a:t>
+              <a:rPr lang="sr-Latn-RS" dirty="0"/>
+              <a:t>    </a:t>
+            </a:r>
+            <a:r>
+              <a:rPr lang="en-US" dirty="0"/>
+              <a:t>&gt;&gt; python project.py</a:t>
             </a:r>
           </a:p>
         </p:txBody>
@@ -17054,277 +16880,175 @@
               </a:rPr>
               <a:t>: </a:t>
             </a:r>
-            <a:endParaRPr lang="en-US" sz="2200" dirty="0"/>
-          </a:p>
-          <a:p>
-            <a:pPr marL="0" indent="0">
-              <a:buNone/>
-            </a:pPr>
-            <a:r>
-              <a:rPr lang="en-US" sz="2200" dirty="0">
-                <a:ea typeface="+mn-lt"/>
-                <a:cs typeface="+mn-lt"/>
-              </a:rPr>
-              <a:t>  -</a:t>
-            </a:r>
-            <a:r>
-              <a:rPr lang="en-US" sz="2200" dirty="0" err="1">
+            <a:endParaRPr lang="sr-Latn-RS" sz="2200" dirty="0">
+              <a:ea typeface="+mn-lt"/>
+              <a:cs typeface="+mn-lt"/>
+            </a:endParaRPr>
+          </a:p>
+          <a:p>
+            <a:pPr lvl="1"/>
+            <a:r>
+              <a:rPr lang="en-US" sz="1800" dirty="0" err="1">
                 <a:ea typeface="+mn-lt"/>
                 <a:cs typeface="+mn-lt"/>
               </a:rPr>
               <a:t>učitavanje</a:t>
             </a:r>
             <a:r>
-              <a:rPr lang="en-US" sz="2200" dirty="0">
+              <a:rPr lang="en-US" sz="1800" dirty="0">
                 <a:ea typeface="+mn-lt"/>
                 <a:cs typeface="+mn-lt"/>
               </a:rPr>
               <a:t> CSV </a:t>
             </a:r>
             <a:r>
-              <a:rPr lang="en-US" sz="2200" dirty="0" err="1">
+              <a:rPr lang="en-US" sz="1800" dirty="0" err="1">
                 <a:ea typeface="+mn-lt"/>
                 <a:cs typeface="+mn-lt"/>
               </a:rPr>
               <a:t>fajla</a:t>
             </a:r>
             <a:r>
-              <a:rPr lang="en-US" sz="2200" dirty="0">
+              <a:rPr lang="en-US" sz="1800" dirty="0">
                 <a:ea typeface="+mn-lt"/>
                 <a:cs typeface="+mn-lt"/>
               </a:rPr>
               <a:t> koji </a:t>
             </a:r>
             <a:r>
-              <a:rPr lang="en-US" sz="2200" dirty="0" err="1">
+              <a:rPr lang="en-US" sz="1800" dirty="0" err="1">
                 <a:ea typeface="+mn-lt"/>
                 <a:cs typeface="+mn-lt"/>
               </a:rPr>
               <a:t>sadrži</a:t>
             </a:r>
             <a:r>
-              <a:rPr lang="en-US" sz="2200" dirty="0">
+              <a:rPr lang="en-US" sz="1800" dirty="0">
                 <a:ea typeface="+mn-lt"/>
                 <a:cs typeface="+mn-lt"/>
               </a:rPr>
               <a:t> </a:t>
             </a:r>
             <a:r>
-              <a:rPr lang="en-US" sz="2200" dirty="0" err="1">
+              <a:rPr lang="en-US" sz="1800" dirty="0" err="1">
                 <a:ea typeface="+mn-lt"/>
                 <a:cs typeface="+mn-lt"/>
               </a:rPr>
               <a:t>putanje</a:t>
             </a:r>
             <a:r>
-              <a:rPr lang="en-US" sz="2200" dirty="0">
+              <a:rPr lang="en-US" sz="1800" dirty="0">
                 <a:ea typeface="+mn-lt"/>
                 <a:cs typeface="+mn-lt"/>
               </a:rPr>
               <a:t> do </a:t>
             </a:r>
             <a:r>
-              <a:rPr lang="en-US" sz="2200" dirty="0" err="1">
+              <a:rPr lang="en-US" sz="1800" dirty="0" err="1">
                 <a:ea typeface="+mn-lt"/>
                 <a:cs typeface="+mn-lt"/>
               </a:rPr>
               <a:t>slika</a:t>
             </a:r>
             <a:r>
-              <a:rPr lang="en-US" sz="2200" dirty="0">
+              <a:rPr lang="en-US" sz="1800" dirty="0">
                 <a:ea typeface="+mn-lt"/>
                 <a:cs typeface="+mn-lt"/>
               </a:rPr>
               <a:t> </a:t>
             </a:r>
             <a:r>
-              <a:rPr lang="en-US" sz="2200" dirty="0" err="1">
+              <a:rPr lang="en-US" sz="1800" dirty="0" err="1">
                 <a:ea typeface="+mn-lt"/>
                 <a:cs typeface="+mn-lt"/>
               </a:rPr>
               <a:t>i</a:t>
             </a:r>
             <a:r>
-              <a:rPr lang="en-US" sz="2200" dirty="0">
+              <a:rPr lang="en-US" sz="1800" dirty="0">
                 <a:ea typeface="+mn-lt"/>
                 <a:cs typeface="+mn-lt"/>
               </a:rPr>
               <a:t> </a:t>
             </a:r>
             <a:r>
-              <a:rPr lang="en-US" sz="2200" dirty="0" err="1">
+              <a:rPr lang="en-US" sz="1800" dirty="0" err="1">
                 <a:ea typeface="+mn-lt"/>
                 <a:cs typeface="+mn-lt"/>
               </a:rPr>
               <a:t>vrednosti</a:t>
             </a:r>
             <a:r>
-              <a:rPr lang="en-US" sz="2200" dirty="0">
+              <a:rPr lang="en-US" sz="1800" dirty="0">
                 <a:ea typeface="+mn-lt"/>
                 <a:cs typeface="+mn-lt"/>
               </a:rPr>
               <a:t> steering angle</a:t>
             </a:r>
-            <a:endParaRPr lang="en-US" sz="2200" dirty="0"/>
-          </a:p>
-          <a:p>
-            <a:pPr marL="0" indent="0">
-              <a:buNone/>
-            </a:pPr>
-            <a:r>
-              <a:rPr lang="en-US" sz="2200" dirty="0">
-                <a:ea typeface="+mn-lt"/>
-                <a:cs typeface="+mn-lt"/>
-              </a:rPr>
-              <a:t>  -</a:t>
-            </a:r>
-            <a:r>
-              <a:rPr lang="en-US" sz="2200" dirty="0" err="1">
-                <a:ea typeface="+mn-lt"/>
-                <a:cs typeface="+mn-lt"/>
-              </a:rPr>
-              <a:t>promena</a:t>
-            </a:r>
-            <a:r>
-              <a:rPr lang="en-US" sz="2200" dirty="0">
+            <a:endParaRPr lang="sr-Latn-RS" sz="1800" dirty="0">
+              <a:ea typeface="+mn-lt"/>
+              <a:cs typeface="+mn-lt"/>
+            </a:endParaRPr>
+          </a:p>
+          <a:p>
+            <a:pPr lvl="1"/>
+            <a:r>
+              <a:rPr lang="en-US" sz="1800" dirty="0" err="1">
+                <a:ea typeface="+mn-lt"/>
+                <a:cs typeface="+mn-lt"/>
+              </a:rPr>
+              <a:t>učitavanje</a:t>
+            </a:r>
+            <a:r>
+              <a:rPr lang="en-US" sz="1800" dirty="0">
                 <a:ea typeface="+mn-lt"/>
                 <a:cs typeface="+mn-lt"/>
               </a:rPr>
               <a:t> </a:t>
             </a:r>
             <a:r>
-              <a:rPr lang="en-US" sz="2200" dirty="0" err="1">
-                <a:ea typeface="+mn-lt"/>
-                <a:cs typeface="+mn-lt"/>
-              </a:rPr>
-              <a:t>apsolutnih</a:t>
-            </a:r>
-            <a:r>
-              <a:rPr lang="en-US" sz="2200" dirty="0">
+              <a:rPr lang="en-US" sz="1800" dirty="0" err="1">
+                <a:ea typeface="+mn-lt"/>
+                <a:cs typeface="+mn-lt"/>
+              </a:rPr>
+              <a:t>slika</a:t>
+            </a:r>
+            <a:r>
+              <a:rPr lang="en-US" sz="1800" dirty="0">
                 <a:ea typeface="+mn-lt"/>
                 <a:cs typeface="+mn-lt"/>
               </a:rPr>
               <a:t> </a:t>
             </a:r>
             <a:r>
-              <a:rPr lang="en-US" sz="2200" dirty="0" err="1">
-                <a:ea typeface="+mn-lt"/>
-                <a:cs typeface="+mn-lt"/>
-              </a:rPr>
-              <a:t>putanja</a:t>
-            </a:r>
-            <a:r>
-              <a:rPr lang="en-US" sz="2200" dirty="0">
+              <a:rPr lang="en-US" sz="1800" dirty="0" err="1">
+                <a:ea typeface="+mn-lt"/>
+                <a:cs typeface="+mn-lt"/>
+              </a:rPr>
+              <a:t>iz</a:t>
+            </a:r>
+            <a:r>
+              <a:rPr lang="en-US" sz="1800" dirty="0">
                 <a:ea typeface="+mn-lt"/>
                 <a:cs typeface="+mn-lt"/>
               </a:rPr>
               <a:t> </a:t>
             </a:r>
             <a:r>
-              <a:rPr lang="en-US" sz="2200" dirty="0" err="1">
-                <a:ea typeface="+mn-lt"/>
-                <a:cs typeface="+mn-lt"/>
-              </a:rPr>
-              <a:t>slika</a:t>
-            </a:r>
-            <a:r>
-              <a:rPr lang="en-US" sz="2200" dirty="0">
-                <a:ea typeface="+mn-lt"/>
-                <a:cs typeface="+mn-lt"/>
-              </a:rPr>
-              <a:t> u </a:t>
-            </a:r>
-            <a:r>
-              <a:rPr lang="en-US" sz="2200" dirty="0" err="1">
-                <a:ea typeface="+mn-lt"/>
-                <a:cs typeface="+mn-lt"/>
-              </a:rPr>
-              <a:t>relativne</a:t>
-            </a:r>
-            <a:r>
-              <a:rPr lang="en-US" sz="2200" dirty="0">
-                <a:ea typeface="+mn-lt"/>
-                <a:cs typeface="+mn-lt"/>
-              </a:rPr>
-              <a:t> </a:t>
-            </a:r>
-            <a:r>
-              <a:rPr lang="en-US" sz="2200" dirty="0" err="1">
-                <a:ea typeface="+mn-lt"/>
-                <a:cs typeface="+mn-lt"/>
-              </a:rPr>
-              <a:t>putanje</a:t>
-            </a:r>
-            <a:endParaRPr lang="en-US" sz="2200" dirty="0"/>
-          </a:p>
-          <a:p>
-            <a:pPr marL="0" indent="0">
-              <a:buNone/>
-            </a:pPr>
-            <a:r>
-              <a:rPr lang="en-US" sz="2200" dirty="0">
-                <a:ea typeface="+mn-lt"/>
-                <a:cs typeface="+mn-lt"/>
-              </a:rPr>
-              <a:t>  -</a:t>
-            </a:r>
-            <a:r>
-              <a:rPr lang="en-US" sz="2200" dirty="0" err="1">
-                <a:ea typeface="+mn-lt"/>
-                <a:cs typeface="+mn-lt"/>
-              </a:rPr>
-              <a:t>učitavanje</a:t>
-            </a:r>
-            <a:r>
-              <a:rPr lang="en-US" sz="2200" dirty="0">
-                <a:ea typeface="+mn-lt"/>
-                <a:cs typeface="+mn-lt"/>
-              </a:rPr>
-              <a:t> </a:t>
-            </a:r>
-            <a:r>
-              <a:rPr lang="en-US" sz="2200" dirty="0" err="1">
-                <a:ea typeface="+mn-lt"/>
-                <a:cs typeface="+mn-lt"/>
-              </a:rPr>
-              <a:t>slika</a:t>
-            </a:r>
-            <a:r>
-              <a:rPr lang="en-US" sz="2200" dirty="0">
-                <a:ea typeface="+mn-lt"/>
-                <a:cs typeface="+mn-lt"/>
-              </a:rPr>
-              <a:t> </a:t>
-            </a:r>
-            <a:r>
-              <a:rPr lang="en-US" sz="2200" dirty="0" err="1">
-                <a:ea typeface="+mn-lt"/>
-                <a:cs typeface="+mn-lt"/>
-              </a:rPr>
-              <a:t>iz</a:t>
-            </a:r>
-            <a:r>
-              <a:rPr lang="en-US" sz="2200" dirty="0">
-                <a:ea typeface="+mn-lt"/>
-                <a:cs typeface="+mn-lt"/>
-              </a:rPr>
-              <a:t> </a:t>
-            </a:r>
-            <a:r>
-              <a:rPr lang="en-US" sz="2200" dirty="0" err="1">
+              <a:rPr lang="en-US" sz="1800" dirty="0" err="1">
                 <a:ea typeface="+mn-lt"/>
                 <a:cs typeface="+mn-lt"/>
               </a:rPr>
               <a:t>foldera</a:t>
             </a:r>
             <a:r>
-              <a:rPr lang="en-US" sz="2200" dirty="0">
+              <a:rPr lang="en-US" sz="1800" dirty="0">
                 <a:ea typeface="+mn-lt"/>
                 <a:cs typeface="+mn-lt"/>
               </a:rPr>
               <a:t> IMG</a:t>
             </a:r>
-            <a:endParaRPr lang="en-US" sz="2200" dirty="0"/>
+            <a:endParaRPr lang="en-US" sz="1800" dirty="0"/>
           </a:p>
           <a:p>
             <a:r>
@@ -17343,214 +17067,193 @@
               <a:rPr lang="en-US" sz="2200" dirty="0"/>
               <a:t>:</a:t>
             </a:r>
-          </a:p>
-          <a:p>
-            <a:pPr marL="0" indent="0">
-              <a:buNone/>
-            </a:pPr>
-            <a:r>
-              <a:rPr lang="en-US" sz="2200" dirty="0"/>
-              <a:t>  -</a:t>
-            </a:r>
-            <a:r>
-              <a:rPr lang="en-US" sz="2200" dirty="0">
+            <a:endParaRPr lang="sr-Latn-RS" sz="2200" dirty="0"/>
+          </a:p>
+          <a:p>
+            <a:pPr lvl="1"/>
+            <a:r>
+              <a:rPr lang="en-US" sz="1800" dirty="0">
                 <a:ea typeface="+mn-lt"/>
                 <a:cs typeface="+mn-lt"/>
               </a:rPr>
               <a:t>crop </a:t>
             </a:r>
             <a:r>
-              <a:rPr lang="en-US" sz="2200" dirty="0" err="1">
+              <a:rPr lang="en-US" sz="1800" dirty="0" err="1">
                 <a:ea typeface="+mn-lt"/>
                 <a:cs typeface="+mn-lt"/>
               </a:rPr>
               <a:t>slike</a:t>
             </a:r>
             <a:r>
-              <a:rPr lang="en-US" sz="2200" dirty="0">
+              <a:rPr lang="en-US" sz="1800" dirty="0">
                 <a:ea typeface="+mn-lt"/>
                 <a:cs typeface="+mn-lt"/>
               </a:rPr>
               <a:t> – </a:t>
             </a:r>
             <a:r>
-              <a:rPr lang="en-US" sz="2200" dirty="0" err="1">
+              <a:rPr lang="en-US" sz="1800" dirty="0" err="1">
                 <a:ea typeface="+mn-lt"/>
                 <a:cs typeface="+mn-lt"/>
               </a:rPr>
               <a:t>uklanjanje</a:t>
             </a:r>
             <a:r>
-              <a:rPr lang="en-US" sz="2200" dirty="0">
+              <a:rPr lang="en-US" sz="1800" dirty="0">
                 <a:ea typeface="+mn-lt"/>
                 <a:cs typeface="+mn-lt"/>
               </a:rPr>
               <a:t> </a:t>
             </a:r>
             <a:r>
-              <a:rPr lang="en-US" sz="2200" dirty="0" err="1">
+              <a:rPr lang="en-US" sz="1800" dirty="0" err="1">
                 <a:ea typeface="+mn-lt"/>
                 <a:cs typeface="+mn-lt"/>
               </a:rPr>
               <a:t>neba</a:t>
             </a:r>
             <a:r>
-              <a:rPr lang="en-US" sz="2200" dirty="0">
+              <a:rPr lang="en-US" sz="1800" dirty="0">
                 <a:ea typeface="+mn-lt"/>
                 <a:cs typeface="+mn-lt"/>
               </a:rPr>
               <a:t> </a:t>
             </a:r>
             <a:r>
-              <a:rPr lang="en-US" sz="2200" dirty="0" err="1">
+              <a:rPr lang="en-US" sz="1800" dirty="0" err="1">
                 <a:ea typeface="+mn-lt"/>
                 <a:cs typeface="+mn-lt"/>
               </a:rPr>
               <a:t>i</a:t>
             </a:r>
             <a:r>
-              <a:rPr lang="en-US" sz="2200" dirty="0">
+              <a:rPr lang="en-US" sz="1800" dirty="0">
                 <a:ea typeface="+mn-lt"/>
                 <a:cs typeface="+mn-lt"/>
               </a:rPr>
               <a:t> </a:t>
             </a:r>
             <a:r>
-              <a:rPr lang="en-US" sz="2200" dirty="0" err="1">
+              <a:rPr lang="en-US" sz="1800" dirty="0" err="1">
                 <a:ea typeface="+mn-lt"/>
                 <a:cs typeface="+mn-lt"/>
               </a:rPr>
               <a:t>haube</a:t>
             </a:r>
             <a:r>
-              <a:rPr lang="en-US" sz="2200" dirty="0">
+              <a:rPr lang="en-US" sz="1800" dirty="0">
                 <a:ea typeface="+mn-lt"/>
                 <a:cs typeface="+mn-lt"/>
               </a:rPr>
               <a:t> </a:t>
             </a:r>
             <a:r>
-              <a:rPr lang="en-US" sz="2200" dirty="0" err="1">
+              <a:rPr lang="en-US" sz="1800" dirty="0" err="1">
                 <a:ea typeface="+mn-lt"/>
                 <a:cs typeface="+mn-lt"/>
               </a:rPr>
               <a:t>vozila</a:t>
             </a:r>
-            <a:endParaRPr lang="en-US" sz="2200" dirty="0"/>
-          </a:p>
-          <a:p>
-            <a:pPr marL="0" indent="0">
-              <a:buNone/>
-            </a:pPr>
-            <a:r>
-              <a:rPr lang="en-US" sz="2200" dirty="0">
-                <a:ea typeface="+mn-lt"/>
-                <a:cs typeface="+mn-lt"/>
-              </a:rPr>
-              <a:t>  -</a:t>
-            </a:r>
-            <a:r>
-              <a:rPr lang="en-US" sz="2200" dirty="0" err="1">
+            <a:endParaRPr lang="sr-Latn-RS" sz="1800" dirty="0">
+              <a:ea typeface="+mn-lt"/>
+              <a:cs typeface="+mn-lt"/>
+            </a:endParaRPr>
+          </a:p>
+          <a:p>
+            <a:pPr lvl="1"/>
+            <a:r>
+              <a:rPr lang="en-US" sz="1800" dirty="0" err="1">
                 <a:ea typeface="+mn-lt"/>
                 <a:cs typeface="+mn-lt"/>
               </a:rPr>
               <a:t>promena</a:t>
             </a:r>
             <a:r>
-              <a:rPr lang="en-US" sz="2200" dirty="0">
+              <a:rPr lang="en-US" sz="1800" dirty="0">
                 <a:ea typeface="+mn-lt"/>
                 <a:cs typeface="+mn-lt"/>
               </a:rPr>
               <a:t> </a:t>
             </a:r>
             <a:r>
-              <a:rPr lang="en-US" sz="2200" dirty="0" err="1">
+              <a:rPr lang="en-US" sz="1800" dirty="0" err="1">
                 <a:ea typeface="+mn-lt"/>
                 <a:cs typeface="+mn-lt"/>
               </a:rPr>
               <a:t>rezolucije</a:t>
             </a:r>
             <a:r>
-              <a:rPr lang="en-US" sz="2200" dirty="0">
+              <a:rPr lang="en-US" sz="1800" dirty="0">
                 <a:ea typeface="+mn-lt"/>
                 <a:cs typeface="+mn-lt"/>
               </a:rPr>
               <a:t> </a:t>
             </a:r>
             <a:r>
-              <a:rPr lang="en-US" sz="2200" dirty="0" err="1">
+              <a:rPr lang="en-US" sz="1800" dirty="0" err="1">
                 <a:ea typeface="+mn-lt"/>
                 <a:cs typeface="+mn-lt"/>
               </a:rPr>
               <a:t>sa</a:t>
             </a:r>
             <a:r>
-              <a:rPr lang="en-US" sz="2200" dirty="0">
+              <a:rPr lang="en-US" sz="1800" dirty="0">
                 <a:ea typeface="+mn-lt"/>
                 <a:cs typeface="+mn-lt"/>
               </a:rPr>
               <a:t> 160×320 → 66×200</a:t>
             </a:r>
-            <a:endParaRPr lang="en-US" sz="2200" dirty="0"/>
-          </a:p>
-          <a:p>
-            <a:pPr marL="0" indent="0">
-              <a:buNone/>
-            </a:pPr>
-            <a:r>
-              <a:rPr lang="en-US" sz="2200" dirty="0"/>
-              <a:t>  </a:t>
-            </a:r>
-            <a:r>
-              <a:rPr lang="en-US" sz="2200" dirty="0">
-                <a:ea typeface="+mn-lt"/>
-                <a:cs typeface="+mn-lt"/>
-              </a:rPr>
-              <a:t>-</a:t>
-            </a:r>
-            <a:r>
-              <a:rPr lang="en-US" sz="2200" dirty="0" err="1">
+            <a:endParaRPr lang="sr-Latn-RS" sz="1800" dirty="0">
+              <a:ea typeface="+mn-lt"/>
+              <a:cs typeface="+mn-lt"/>
+            </a:endParaRPr>
+          </a:p>
+          <a:p>
+            <a:pPr lvl="1"/>
+            <a:r>
+              <a:rPr lang="en-US" sz="1800" dirty="0" err="1">
                 <a:ea typeface="+mn-lt"/>
                 <a:cs typeface="+mn-lt"/>
               </a:rPr>
               <a:t>normalizacija</a:t>
             </a:r>
             <a:r>
-              <a:rPr lang="en-US" sz="2200" dirty="0">
+              <a:rPr lang="en-US" sz="1800" dirty="0">
                 <a:ea typeface="+mn-lt"/>
                 <a:cs typeface="+mn-lt"/>
               </a:rPr>
               <a:t> </a:t>
             </a:r>
             <a:r>
-              <a:rPr lang="en-US" sz="2200" dirty="0" err="1">
+              <a:rPr lang="en-US" sz="1800" dirty="0" err="1">
                 <a:ea typeface="+mn-lt"/>
                 <a:cs typeface="+mn-lt"/>
               </a:rPr>
               <a:t>piksela</a:t>
             </a:r>
             <a:r>
-              <a:rPr lang="en-US" sz="2200" dirty="0">
+              <a:rPr lang="en-US" sz="1800" dirty="0">
                 <a:ea typeface="+mn-lt"/>
                 <a:cs typeface="+mn-lt"/>
               </a:rPr>
               <a:t> (</a:t>
             </a:r>
             <a:r>
-              <a:rPr lang="en-US" sz="2200" dirty="0" err="1">
+              <a:rPr lang="en-US" sz="1800" dirty="0" err="1">
                 <a:ea typeface="+mn-lt"/>
                 <a:cs typeface="+mn-lt"/>
               </a:rPr>
               <a:t>opseg</a:t>
             </a:r>
             <a:r>
-              <a:rPr lang="en-US" sz="2200" dirty="0">
+              <a:rPr lang="en-US" sz="1800" dirty="0">
                 <a:ea typeface="+mn-lt"/>
                 <a:cs typeface="+mn-lt"/>
               </a:rPr>
               <a:t> 0–255 → 0–1)</a:t>
             </a:r>
-            <a:endParaRPr lang="en-US" sz="2200" dirty="0"/>
+            <a:endParaRPr lang="en-US" sz="1800" dirty="0"/>
           </a:p>
           <a:p>
             <a:r>
@@ -17591,7 +17294,15 @@
             </a:r>
             <a:r>
               <a:rPr lang="en-US" sz="2200" dirty="0"/>
-              <a:t>( 80%) I test </a:t>
+              <a:t>(80%) </a:t>
+            </a:r>
+            <a:r>
+              <a:rPr lang="sr-Latn-RS" sz="2200" dirty="0"/>
+              <a:t>i</a:t>
+            </a:r>
+            <a:r>
+              <a:rPr lang="en-US" sz="2200" dirty="0"/>
+              <a:t> test </a:t>
             </a:r>
             <a:r>
               <a:rPr lang="en-US" sz="2200" dirty="0" err="1"/>
@@ -17603,7 +17314,7 @@
             </a:r>
           </a:p>
           <a:p>
-            <a:endParaRPr lang="en-US"/>
+            <a:endParaRPr lang="en-US" dirty="0"/>
           </a:p>
         </p:txBody>
       </p:sp>
@@ -17656,7 +17367,7 @@
         <p:spPr>
           <a:xfrm>
             <a:off x="878005" y="405635"/>
-            <a:ext cx="9905999" cy="3908602"/>
+            <a:ext cx="9905999" cy="6172718"/>
           </a:xfrm>
         </p:spPr>
         <p:txBody>
@@ -17714,31 +17425,95 @@
               </a:rPr>
               <a:t>:</a:t>
             </a:r>
-            <a:endParaRPr lang="en-US"/>
-          </a:p>
-          <a:p>
-            <a:pPr marL="0" indent="0">
-              <a:buNone/>
-            </a:pPr>
+            <a:endParaRPr lang="sr-Latn-RS" dirty="0">
+              <a:ea typeface="+mn-lt"/>
+              <a:cs typeface="+mn-lt"/>
+            </a:endParaRPr>
+          </a:p>
+          <a:p>
+            <a:pPr lvl="1"/>
+            <a:r>
+              <a:rPr lang="en-US" dirty="0" err="1">
+                <a:ea typeface="+mn-lt"/>
+                <a:cs typeface="+mn-lt"/>
+              </a:rPr>
+              <a:t>učitava</a:t>
+            </a:r>
             <a:r>
               <a:rPr lang="en-US" dirty="0">
                 <a:ea typeface="+mn-lt"/>
                 <a:cs typeface="+mn-lt"/>
               </a:rPr>
-              <a:t>  - </a:t>
+              <a:t> se </a:t>
             </a:r>
             <a:r>
               <a:rPr lang="en-US" dirty="0" err="1">
                 <a:ea typeface="+mn-lt"/>
                 <a:cs typeface="+mn-lt"/>
               </a:rPr>
-              <a:t>učitava</a:t>
+              <a:t>slika</a:t>
             </a:r>
             <a:r>
               <a:rPr lang="en-US" dirty="0">
                 <a:ea typeface="+mn-lt"/>
                 <a:cs typeface="+mn-lt"/>
               </a:rPr>
+              <a:t> </a:t>
+            </a:r>
+            <a:r>
+              <a:rPr lang="en-US" dirty="0" err="1">
+                <a:ea typeface="+mn-lt"/>
+                <a:cs typeface="+mn-lt"/>
+              </a:rPr>
+              <a:t>sa</a:t>
+            </a:r>
+            <a:r>
+              <a:rPr lang="en-US" dirty="0">
+                <a:ea typeface="+mn-lt"/>
+                <a:cs typeface="+mn-lt"/>
+              </a:rPr>
+              <a:t> </a:t>
+            </a:r>
+            <a:r>
+              <a:rPr lang="en-US" dirty="0" err="1">
+                <a:ea typeface="+mn-lt"/>
+                <a:cs typeface="+mn-lt"/>
+              </a:rPr>
+              <a:t>centralne</a:t>
+            </a:r>
+            <a:r>
+              <a:rPr lang="en-US" dirty="0">
+                <a:ea typeface="+mn-lt"/>
+                <a:cs typeface="+mn-lt"/>
+              </a:rPr>
+              <a:t> </a:t>
+            </a:r>
+            <a:r>
+              <a:rPr lang="en-US" dirty="0" err="1">
+                <a:ea typeface="+mn-lt"/>
+                <a:cs typeface="+mn-lt"/>
+              </a:rPr>
+              <a:t>kamere</a:t>
+            </a:r>
+            <a:endParaRPr lang="sr-Latn-RS" dirty="0">
+              <a:ea typeface="+mn-lt"/>
+              <a:cs typeface="+mn-lt"/>
+            </a:endParaRPr>
+          </a:p>
+          <a:p>
+            <a:pPr lvl="1"/>
+            <a:r>
+              <a:rPr lang="en-US" dirty="0" err="1">
+                <a:ea typeface="+mn-lt"/>
+                <a:cs typeface="+mn-lt"/>
+              </a:rPr>
+              <a:t>primenjuje</a:t>
+            </a:r>
+            <a:r>
+              <a:rPr lang="en-US" dirty="0">
+                <a:ea typeface="+mn-lt"/>
+                <a:cs typeface="+mn-lt"/>
+              </a:rPr>
               <a:t> se </a:t>
             </a:r>
             <a:r>
@@ -17746,6 +17521,41 @@
                 <a:ea typeface="+mn-lt"/>
                 <a:cs typeface="+mn-lt"/>
               </a:rPr>
+              <a:t>funkcija</a:t>
+            </a:r>
+            <a:r>
+              <a:rPr lang="en-US" dirty="0">
+                <a:ea typeface="+mn-lt"/>
+                <a:cs typeface="+mn-lt"/>
+              </a:rPr>
+              <a:t> </a:t>
+            </a:r>
+            <a:r>
+              <a:rPr lang="en-US" dirty="0" err="1">
+                <a:ea typeface="+mn-lt"/>
+                <a:cs typeface="+mn-lt"/>
+              </a:rPr>
+              <a:t>load_image</a:t>
+            </a:r>
+            <a:r>
+              <a:rPr lang="en-US" dirty="0">
+                <a:ea typeface="+mn-lt"/>
+                <a:cs typeface="+mn-lt"/>
+              </a:rPr>
+              <a:t>()</a:t>
+            </a:r>
+            <a:endParaRPr lang="sr-Latn-RS" dirty="0">
+              <a:ea typeface="+mn-lt"/>
+              <a:cs typeface="+mn-lt"/>
+            </a:endParaRPr>
+          </a:p>
+          <a:p>
+            <a:pPr lvl="1"/>
+            <a:r>
+              <a:rPr lang="en-US" dirty="0" err="1">
+                <a:ea typeface="+mn-lt"/>
+                <a:cs typeface="+mn-lt"/>
+              </a:rPr>
               <a:t>slika</a:t>
             </a:r>
             <a:r>
@@ -17753,6 +17563,34 @@
                 <a:ea typeface="+mn-lt"/>
                 <a:cs typeface="+mn-lt"/>
               </a:rPr>
+              <a:t> se </a:t>
+            </a:r>
+            <a:r>
+              <a:rPr lang="en-US" dirty="0" err="1">
+                <a:ea typeface="+mn-lt"/>
+                <a:cs typeface="+mn-lt"/>
+              </a:rPr>
+              <a:t>dodaje</a:t>
+            </a:r>
+            <a:r>
+              <a:rPr lang="en-US" dirty="0">
+                <a:ea typeface="+mn-lt"/>
+                <a:cs typeface="+mn-lt"/>
+              </a:rPr>
+              <a:t> u </a:t>
+            </a:r>
+            <a:r>
+              <a:rPr lang="en-US" dirty="0" err="1">
+                <a:ea typeface="+mn-lt"/>
+                <a:cs typeface="+mn-lt"/>
+              </a:rPr>
+              <a:t>niz</a:t>
+            </a:r>
+            <a:r>
+              <a:rPr lang="en-US" dirty="0">
+                <a:ea typeface="+mn-lt"/>
+                <a:cs typeface="+mn-lt"/>
+              </a:rPr>
               <a:t> </a:t>
             </a:r>
             <a:r>
@@ -17760,7 +17598,21 @@
                 <a:ea typeface="+mn-lt"/>
                 <a:cs typeface="+mn-lt"/>
               </a:rPr>
-              <a:t>sa</a:t>
+              <a:t>train_images</a:t>
+            </a:r>
+            <a:endParaRPr lang="sr-Latn-RS" dirty="0">
+              <a:ea typeface="+mn-lt"/>
+              <a:cs typeface="+mn-lt"/>
+            </a:endParaRPr>
+          </a:p>
+          <a:p>
+            <a:pPr lvl="1"/>
+            <a:r>
+              <a:rPr lang="en-US" dirty="0" err="1">
+                <a:ea typeface="+mn-lt"/>
+                <a:cs typeface="+mn-lt"/>
+              </a:rPr>
+              <a:t>odgovarajući</a:t>
             </a:r>
             <a:r>
               <a:rPr lang="en-US" dirty="0">
@@ -17774,7 +17626,7 @@
                 <a:ea typeface="+mn-lt"/>
                 <a:cs typeface="+mn-lt"/>
               </a:rPr>
-              <a:t>centralne</a:t>
+              <a:t>ugao</a:t>
             </a:r>
             <a:r>
               <a:rPr lang="en-US" dirty="0">
@@ -17788,329 +17640,72 @@
                 <a:ea typeface="+mn-lt"/>
                 <a:cs typeface="+mn-lt"/>
               </a:rPr>
-              <a:t>kamere</a:t>
-            </a:r>
-            <a:endParaRPr lang="en-US"/>
-          </a:p>
-          <a:p>
-            <a:pPr marL="0" indent="0">
-              <a:buNone/>
-            </a:pPr>
+              <a:t>upravljanja</a:t>
+            </a:r>
             <a:r>
               <a:rPr lang="en-US" dirty="0">
                 <a:ea typeface="+mn-lt"/>
                 <a:cs typeface="+mn-lt"/>
               </a:rPr>
-              <a:t>  - </a:t>
+              <a:t> </a:t>
             </a:r>
             <a:r>
               <a:rPr lang="en-US" dirty="0" err="1">
                 <a:ea typeface="+mn-lt"/>
                 <a:cs typeface="+mn-lt"/>
               </a:rPr>
-              <a:t>primenjuje</a:t>
+              <a:t>dodaje</a:t>
             </a:r>
             <a:r>
               <a:rPr lang="en-US" dirty="0">
                 <a:ea typeface="+mn-lt"/>
                 <a:cs typeface="+mn-lt"/>
               </a:rPr>
-              <a:t> se </a:t>
+              <a:t> se u </a:t>
             </a:r>
             <a:r>
               <a:rPr lang="en-US" dirty="0" err="1">
                 <a:ea typeface="+mn-lt"/>
                 <a:cs typeface="+mn-lt"/>
               </a:rPr>
-              <a:t>funkcija</a:t>
-            </a:r>
-            <a:r>
-              <a:rPr lang="en-US" dirty="0">
-                <a:ea typeface="+mn-lt"/>
-                <a:cs typeface="+mn-lt"/>
-              </a:rPr>
-              <a:t> </a:t>
-            </a:r>
-            <a:r>
-              <a:rPr lang="en-US" dirty="0" err="1">
-                <a:ea typeface="+mn-lt"/>
-                <a:cs typeface="+mn-lt"/>
-              </a:rPr>
-              <a:t>load_image</a:t>
-            </a:r>
-            <a:r>
-              <a:rPr lang="en-US" dirty="0">
-                <a:ea typeface="+mn-lt"/>
-                <a:cs typeface="+mn-lt"/>
-              </a:rPr>
-              <a:t>()</a:t>
-            </a:r>
-            <a:endParaRPr lang="en-US"/>
-          </a:p>
-          <a:p>
-            <a:pPr marL="0" indent="0">
-              <a:buNone/>
-            </a:pPr>
-            <a:r>
-              <a:rPr lang="en-US" dirty="0">
-                <a:ea typeface="+mn-lt"/>
-                <a:cs typeface="+mn-lt"/>
-              </a:rPr>
-              <a:t>  - </a:t>
-            </a:r>
-            <a:r>
-              <a:rPr lang="en-US" dirty="0" err="1">
-                <a:ea typeface="+mn-lt"/>
-                <a:cs typeface="+mn-lt"/>
-              </a:rPr>
-              <a:t>slika</a:t>
-            </a:r>
-            <a:r>
-              <a:rPr lang="en-US" dirty="0">
-                <a:ea typeface="+mn-lt"/>
-                <a:cs typeface="+mn-lt"/>
-              </a:rPr>
-              <a:t> se </a:t>
-            </a:r>
-            <a:r>
-              <a:rPr lang="en-US" dirty="0" err="1">
-                <a:ea typeface="+mn-lt"/>
-                <a:cs typeface="+mn-lt"/>
-              </a:rPr>
-              <a:t>dodaje</a:t>
-            </a:r>
-            <a:r>
-              <a:rPr lang="en-US" dirty="0">
-                <a:ea typeface="+mn-lt"/>
-                <a:cs typeface="+mn-lt"/>
-              </a:rPr>
-              <a:t> u </a:t>
-            </a:r>
-            <a:r>
-              <a:rPr lang="en-US" dirty="0" err="1">
-                <a:ea typeface="+mn-lt"/>
-                <a:cs typeface="+mn-lt"/>
-              </a:rPr>
-              <a:t>niz</a:t>
-            </a:r>
-            <a:r>
-              <a:rPr lang="en-US" dirty="0">
-                <a:ea typeface="+mn-lt"/>
-                <a:cs typeface="+mn-lt"/>
-              </a:rPr>
-              <a:t> </a:t>
-            </a:r>
-            <a:r>
-              <a:rPr lang="en-US" dirty="0" err="1">
-                <a:ea typeface="+mn-lt"/>
-                <a:cs typeface="+mn-lt"/>
-              </a:rPr>
-              <a:t>train_images</a:t>
-            </a:r>
-            <a:endParaRPr lang="en-US"/>
-          </a:p>
-          <a:p>
-            <a:pPr marL="0" indent="0">
-              <a:buNone/>
-            </a:pPr>
-            <a:r>
-              <a:rPr lang="en-US" dirty="0">
-                <a:ea typeface="+mn-lt"/>
-                <a:cs typeface="+mn-lt"/>
-              </a:rPr>
-              <a:t>  - </a:t>
-            </a:r>
-            <a:r>
-              <a:rPr lang="en-US" dirty="0" err="1">
-                <a:ea typeface="+mn-lt"/>
-                <a:cs typeface="+mn-lt"/>
-              </a:rPr>
-              <a:t>odgovarajući</a:t>
-            </a:r>
-            <a:r>
-              <a:rPr lang="en-US" dirty="0">
-                <a:ea typeface="+mn-lt"/>
-                <a:cs typeface="+mn-lt"/>
-              </a:rPr>
-              <a:t> </a:t>
-            </a:r>
-            <a:r>
-              <a:rPr lang="en-US" dirty="0" err="1">
-                <a:ea typeface="+mn-lt"/>
-                <a:cs typeface="+mn-lt"/>
-              </a:rPr>
-              <a:t>ugao</a:t>
-            </a:r>
-            <a:r>
-              <a:rPr lang="en-US" dirty="0">
-                <a:ea typeface="+mn-lt"/>
-                <a:cs typeface="+mn-lt"/>
-              </a:rPr>
-              <a:t> </a:t>
-            </a:r>
-            <a:r>
-              <a:rPr lang="en-US" dirty="0" err="1">
-                <a:ea typeface="+mn-lt"/>
-                <a:cs typeface="+mn-lt"/>
-              </a:rPr>
-              <a:t>upravljanja</a:t>
-            </a:r>
-            <a:r>
-              <a:rPr lang="en-US" dirty="0">
-                <a:ea typeface="+mn-lt"/>
-                <a:cs typeface="+mn-lt"/>
-              </a:rPr>
-              <a:t> </a:t>
-            </a:r>
-            <a:r>
-              <a:rPr lang="en-US" dirty="0" err="1">
-                <a:ea typeface="+mn-lt"/>
-                <a:cs typeface="+mn-lt"/>
-              </a:rPr>
-              <a:t>dodaje</a:t>
-            </a:r>
-            <a:r>
-              <a:rPr lang="en-US" dirty="0">
-                <a:ea typeface="+mn-lt"/>
-                <a:cs typeface="+mn-lt"/>
-              </a:rPr>
-              <a:t> se u </a:t>
-            </a:r>
-            <a:r>
-              <a:rPr lang="en-US" dirty="0" err="1">
-                <a:ea typeface="+mn-lt"/>
-                <a:cs typeface="+mn-lt"/>
-              </a:rPr>
               <a:t>train_angles</a:t>
             </a:r>
-            <a:endParaRPr lang="en-US" dirty="0" err="1"/>
-          </a:p>
-          <a:p>
-            <a:r>
-              <a:rPr lang="en-US" dirty="0" err="1">
-                <a:ea typeface="+mn-lt"/>
-                <a:cs typeface="+mn-lt"/>
-              </a:rPr>
-              <a:t>Podaci</a:t>
-            </a:r>
-            <a:r>
-              <a:rPr lang="en-US" dirty="0">
-                <a:ea typeface="+mn-lt"/>
-                <a:cs typeface="+mn-lt"/>
-              </a:rPr>
-              <a:t> se </a:t>
-            </a:r>
-            <a:r>
-              <a:rPr lang="en-US" dirty="0" err="1">
-                <a:ea typeface="+mn-lt"/>
-                <a:cs typeface="+mn-lt"/>
-              </a:rPr>
-              <a:t>zatim</a:t>
-            </a:r>
-            <a:r>
-              <a:rPr lang="en-US" dirty="0">
-                <a:ea typeface="+mn-lt"/>
-                <a:cs typeface="+mn-lt"/>
-              </a:rPr>
-              <a:t> </a:t>
-            </a:r>
-            <a:r>
-              <a:rPr lang="en-US" dirty="0" err="1">
-                <a:ea typeface="+mn-lt"/>
-                <a:cs typeface="+mn-lt"/>
-              </a:rPr>
-              <a:t>konvertuju</a:t>
-            </a:r>
-            <a:r>
-              <a:rPr lang="en-US" dirty="0">
-                <a:ea typeface="+mn-lt"/>
-                <a:cs typeface="+mn-lt"/>
-              </a:rPr>
-              <a:t> u NumPy </a:t>
-            </a:r>
-            <a:r>
-              <a:rPr lang="en-US" dirty="0" err="1">
-                <a:ea typeface="+mn-lt"/>
-                <a:cs typeface="+mn-lt"/>
-              </a:rPr>
-              <a:t>nizove</a:t>
-            </a:r>
-            <a:r>
-              <a:rPr lang="en-US" dirty="0">
-                <a:ea typeface="+mn-lt"/>
-                <a:cs typeface="+mn-lt"/>
-              </a:rPr>
-              <a:t> </a:t>
-            </a:r>
-            <a:r>
-              <a:rPr lang="en-US" dirty="0" err="1">
-                <a:ea typeface="+mn-lt"/>
-                <a:cs typeface="+mn-lt"/>
-              </a:rPr>
-              <a:t>radi</a:t>
-            </a:r>
-            <a:r>
-              <a:rPr lang="en-US" dirty="0">
-                <a:ea typeface="+mn-lt"/>
-                <a:cs typeface="+mn-lt"/>
-              </a:rPr>
-              <a:t> </a:t>
-            </a:r>
-            <a:r>
-              <a:rPr lang="en-US" dirty="0" err="1">
-                <a:ea typeface="+mn-lt"/>
-                <a:cs typeface="+mn-lt"/>
-              </a:rPr>
-              <a:t>efikasnijeg</a:t>
-            </a:r>
-            <a:r>
-              <a:rPr lang="en-US" dirty="0">
-                <a:ea typeface="+mn-lt"/>
-                <a:cs typeface="+mn-lt"/>
-              </a:rPr>
-              <a:t> rada </a:t>
-            </a:r>
-            <a:r>
-              <a:rPr lang="en-US" dirty="0" err="1">
-                <a:ea typeface="+mn-lt"/>
-                <a:cs typeface="+mn-lt"/>
-              </a:rPr>
-              <a:t>sa</a:t>
-            </a:r>
-            <a:r>
-              <a:rPr lang="en-US" dirty="0">
-                <a:ea typeface="+mn-lt"/>
-                <a:cs typeface="+mn-lt"/>
-              </a:rPr>
-              <a:t> </a:t>
-            </a:r>
-            <a:r>
-              <a:rPr lang="en-US" dirty="0" err="1">
-                <a:ea typeface="+mn-lt"/>
-                <a:cs typeface="+mn-lt"/>
-              </a:rPr>
-              <a:t>neuronskom</a:t>
-            </a:r>
-            <a:r>
-              <a:rPr lang="en-US" dirty="0">
-                <a:ea typeface="+mn-lt"/>
-                <a:cs typeface="+mn-lt"/>
-              </a:rPr>
-              <a:t> </a:t>
-            </a:r>
-            <a:r>
-              <a:rPr lang="en-US" dirty="0" err="1">
-                <a:ea typeface="+mn-lt"/>
-                <a:cs typeface="+mn-lt"/>
-              </a:rPr>
-              <a:t>mrežom</a:t>
-            </a:r>
-            <a:r>
-              <a:rPr lang="en-US" dirty="0">
-                <a:ea typeface="+mn-lt"/>
-                <a:cs typeface="+mn-lt"/>
-              </a:rPr>
-              <a:t>.</a:t>
+            <a:endParaRPr lang="en-US" dirty="0"/>
+          </a:p>
+          <a:p>
+            <a:r>
+              <a:rPr lang="en-US" dirty="0" err="1"/>
+              <a:t>Unapre</a:t>
+            </a:r>
+            <a:r>
+              <a:rPr lang="sr-Latn-RS" dirty="0"/>
+              <a:t>đenje data seta urađeno:</a:t>
+            </a:r>
+          </a:p>
+          <a:p>
+            <a:pPr lvl="1"/>
+            <a:r>
+              <a:rPr lang="sr-Latn-RS" dirty="0"/>
+              <a:t>Augmentacijom - </a:t>
+            </a:r>
+            <a:r>
+              <a:rPr lang="en-US" dirty="0" err="1"/>
+              <a:t>horizontalni</a:t>
+            </a:r>
+            <a:r>
+              <a:rPr lang="en-US" dirty="0"/>
+              <a:t> flip</a:t>
+            </a:r>
+            <a:r>
+              <a:rPr lang="sr-Latn-RS" dirty="0"/>
+              <a:t> slike za abs(angle) &gt; 0.10</a:t>
+            </a:r>
+          </a:p>
+          <a:p>
+            <a:pPr lvl="1"/>
+            <a:r>
+              <a:rPr lang="sr-Latn-RS" dirty="0"/>
+              <a:t>Izbacivanjem 75% slika koje su imale steering angle 0 pošto je većina data seta imala tu vrednost</a:t>
             </a:r>
             <a:endParaRPr lang="en-US" dirty="0"/>
           </a:p>
@@ -18287,13 +17882,6 @@
               </a:rPr>
               <a:t>slike</a:t>
             </a:r>
-            <a:r>
-              <a:rPr lang="en-US" dirty="0">
-                <a:ea typeface="+mn-lt"/>
-                <a:cs typeface="+mn-lt"/>
-              </a:rPr>
-              <a:t>.</a:t>
-            </a:r>
             <a:endParaRPr lang="en-US" dirty="0"/>
           </a:p>
           <a:p>
@@ -18369,11 +17957,11 @@
             </a:r>
             <a:r>
               <a:rPr lang="en-US" dirty="0"/>
-              <a:t> I </a:t>
-            </a:r>
-            <a:r>
-              <a:rPr lang="en-US" dirty="0" err="1"/>
-              <a:t>omoguava</a:t>
+              <a:t> </a:t>
+            </a:r>
+            <a:r>
+              <a:rPr lang="sr-Latn-RS" dirty="0"/>
+              <a:t>i</a:t>
             </a:r>
             <a:r>
               <a:rPr lang="en-US" dirty="0"/>
@@ -18381,6 +17969,18 @@
             </a:r>
             <a:r>
               <a:rPr lang="en-US" dirty="0" err="1"/>
+              <a:t>omogu</a:t>
+            </a:r>
+            <a:r>
+              <a:rPr lang="sr-Latn-RS" dirty="0"/>
+              <a:t>ć</a:t>
+            </a:r>
+            <a:r>
+              <a:rPr lang="en-US" dirty="0"/>
+              <a:t>ava </a:t>
+            </a:r>
+            <a:r>
+              <a:rPr lang="en-US" dirty="0" err="1"/>
               <a:t>predviđanje</a:t>
             </a:r>
             <a:r>
@@ -18671,7 +18271,7 @@
             <a:endParaRPr lang="en-US" dirty="0"/>
           </a:p>
           <a:p>
-            <a:endParaRPr lang="en-US"/>
+            <a:endParaRPr lang="en-US" dirty="0"/>
           </a:p>
         </p:txBody>
       </p:sp>
@@ -19429,7 +19029,7 @@
         </p:nvSpPr>
         <p:spPr>
           <a:xfrm>
-            <a:off x="7158909" y="1822620"/>
+            <a:off x="7162214" y="1917558"/>
             <a:ext cx="4685269" cy="1846659"/>
           </a:xfrm>
           <a:prstGeom prst="rect">
@@ -19460,7 +19060,7 @@
               </a:rPr>
               <a:t> deo:</a:t>
             </a:r>
-            <a:endParaRPr lang="en-US" sz="2400"/>
+            <a:endParaRPr lang="en-US" sz="2400" dirty="0"/>
           </a:p>
           <a:p>
             <a:pPr marL="285750" indent="-285750">
@@ -19752,43 +19352,50 @@
               </a:spcBef>
             </a:pPr>
             <a:r>
-              <a:rPr lang="en-US"/>
+              <a:rPr lang="en-US" dirty="0"/>
               <a:t>Fully connected deo:</a:t>
             </a:r>
-            <a:endParaRPr lang="en-US" dirty="0"/>
-          </a:p>
-          <a:p>
-            <a:pPr marL="0" indent="0">
+            <a:endParaRPr lang="sr-Latn-RS" dirty="0"/>
+          </a:p>
+          <a:p>
+            <a:pPr lvl="1">
               <a:lnSpc>
                 <a:spcPct val="100000"/>
               </a:lnSpc>
               <a:spcBef>
                 <a:spcPts val="0"/>
               </a:spcBef>
-              <a:buNone/>
             </a:pPr>
             <a:r>
               <a:rPr lang="en-US" dirty="0"/>
-              <a:t>  - Dense </a:t>
+              <a:t>Dense </a:t>
             </a:r>
             <a:r>
               <a:rPr lang="en-US" dirty="0" err="1"/>
               <a:t>slojevi</a:t>
             </a:r>
-          </a:p>
-          <a:p>
-            <a:pPr marL="0" indent="0">
+            <a:endParaRPr lang="sr-Latn-RS" dirty="0"/>
+          </a:p>
+          <a:p>
+            <a:pPr>
               <a:lnSpc>
                 <a:spcPct val="100000"/>
               </a:lnSpc>
               <a:spcBef>
                 <a:spcPts val="0"/>
               </a:spcBef>
-              <a:buNone/>
             </a:pPr>
             <a:r>
               <a:rPr lang="en-US" dirty="0"/>
-              <a:t>  - Dropout za </a:t>
+              <a:t>Dropout</a:t>
+            </a:r>
+            <a:r>
+              <a:rPr lang="sr-Latn-RS" dirty="0"/>
+              <a:t>, odbacivanje dela neurona</a:t>
+            </a:r>
+            <a:r>
+              <a:rPr lang="en-US" dirty="0"/>
+              <a:t> za </a:t>
             </a:r>
             <a:r>
               <a:rPr lang="en-US" dirty="0" err="1"/>
@@ -19802,17 +19409,6 @@
               <a:rPr lang="en-US" dirty="0" err="1"/>
               <a:t>overfittinga</a:t>
             </a:r>
-          </a:p>
-          <a:p>
-            <a:pPr marL="0" indent="0">
-              <a:lnSpc>
-                <a:spcPct val="100000"/>
-              </a:lnSpc>
-              <a:spcBef>
-                <a:spcPts val="0"/>
-              </a:spcBef>
-              <a:buNone/>
-            </a:pPr>
             <a:endParaRPr lang="en-US" dirty="0"/>
           </a:p>
           <a:p>
@@ -19867,8 +19463,8 @@
         </p:nvSpPr>
         <p:spPr>
           <a:xfrm>
-            <a:off x="6631459" y="2100649"/>
-            <a:ext cx="4977711" cy="2677656"/>
+            <a:off x="6347535" y="2100649"/>
+            <a:ext cx="5261636" cy="2677656"/>
           </a:xfrm>
           <a:prstGeom prst="rect">
             <a:avLst/>
@@ -19904,24 +19500,38 @@
               <a:rPr lang="en-US" sz="2400" dirty="0"/>
               <a:t>:</a:t>
             </a:r>
-          </a:p>
-          <a:p>
-            <a:r>
-              <a:rPr lang="en-US" sz="2400"/>
-              <a:t>  - Optimizer: Adam</a:t>
-            </a:r>
-            <a:endParaRPr lang="en-US" sz="2400" dirty="0"/>
-          </a:p>
-          <a:p>
-            <a:r>
-              <a:rPr lang="en-US" sz="2400"/>
-              <a:t>  - Learning rate: 0.0001</a:t>
-            </a:r>
-          </a:p>
-          <a:p>
+            <a:endParaRPr lang="sr-Latn-RS" sz="2400" dirty="0"/>
+          </a:p>
+          <a:p>
+            <a:pPr marL="800100" lvl="1" indent="-342900">
+              <a:buFont typeface="Arial"/>
+              <a:buChar char="•"/>
+            </a:pPr>
             <a:r>
               <a:rPr lang="en-US" sz="2400" dirty="0"/>
-              <a:t>  - Loss </a:t>
+              <a:t>Optimizer: Adam</a:t>
+            </a:r>
+            <a:endParaRPr lang="sr-Latn-RS" sz="2400" dirty="0"/>
+          </a:p>
+          <a:p>
+            <a:pPr marL="800100" lvl="1" indent="-342900">
+              <a:buFont typeface="Arial"/>
+              <a:buChar char="•"/>
+            </a:pPr>
+            <a:r>
+              <a:rPr lang="en-US" sz="2400" dirty="0"/>
+              <a:t>Learning rate: 0.0001</a:t>
+            </a:r>
+            <a:endParaRPr lang="sr-Latn-RS" sz="2400" dirty="0"/>
+          </a:p>
+          <a:p>
+            <a:pPr marL="800100" lvl="1" indent="-342900">
+              <a:buFont typeface="Arial"/>
+              <a:buChar char="•"/>
+            </a:pPr>
+            <a:r>
+              <a:rPr lang="en-US" sz="2400" dirty="0"/>
+              <a:t>Loss </a:t>
             </a:r>
             <a:r>
               <a:rPr lang="en-US" sz="2400" dirty="0" err="1"/>
@@ -19929,14 +19539,23 @@
             </a:r>
             <a:r>
               <a:rPr lang="en-US" sz="2400" dirty="0"/>
-              <a:t>: Mean Squared Error (MSE)</a:t>
-            </a:r>
-          </a:p>
-          <a:p>
+              <a:t>: Mean Squared Error</a:t>
+            </a:r>
+            <a:r>
+              <a:rPr lang="sr-Latn-RS" sz="2400" dirty="0"/>
+              <a:t> </a:t>
+            </a:r>
             <a:r>
               <a:rPr lang="en-US" sz="2400" dirty="0"/>
-              <a:t>   - </a:t>
-            </a:r>
+              <a:t>(MSE)</a:t>
+            </a:r>
+            <a:endParaRPr lang="sr-Latn-RS" sz="2400" dirty="0"/>
+          </a:p>
+          <a:p>
+            <a:pPr marL="800100" lvl="1" indent="-342900">
+              <a:buFont typeface="Arial"/>
+              <a:buChar char="•"/>
+            </a:pPr>
             <a:r>
               <a:rPr lang="en-US" sz="2400" dirty="0" err="1"/>
               <a:t>Metrička</a:t>

</xml_diff>